<commit_message>
docs(presentation): assemble verified milestones with French slide descriptions
</commit_message>
<xml_diff>
--- a/docs/presentation/eventsProject-Tache-phase-01.pptx
+++ b/docs/presentation/eventsProject-Tache-phase-01.pptx
@@ -5,7 +5,7 @@
     <p:sldMasterId id="2147483648" r:id="rId1"/>
   </p:sldMasterIdLst>
   <p:notesMasterIdLst>
-    <p:notesMasterId r:id="rId9"/>
+    <p:notesMasterId r:id="rId14"/>
   </p:notesMasterIdLst>
   <p:sldIdLst>
     <p:sldId id="256" r:id="rId2"/>
@@ -15,6 +15,11 @@
     <p:sldId id="260" r:id="rId6"/>
     <p:sldId id="261" r:id="rId7"/>
     <p:sldId id="262" r:id="rId8"/>
+    <p:sldId id="263" r:id="rId9"/>
+    <p:sldId id="264" r:id="rId10"/>
+    <p:sldId id="265" r:id="rId11"/>
+    <p:sldId id="266" r:id="rId12"/>
+    <p:sldId id="267" r:id="rId13"/>
   </p:sldIdLst>
   <p:sldSz cx="12192000" cy="6858000"/>
   <p:notesSz cx="6858000" cy="9144000"/>
@@ -196,7 +201,7 @@
             </a:lvl1pPr>
           </a:lstStyle>
           <a:p>
-            <a:fld id="{ADF292F3-ED02-4EEE-B086-86F4F6F7ECA4}" type="datetimeFigureOut">
+            <a:fld id="{DDAF4E28-6F1D-4896-B4D9-800311CAE4E4}" type="datetimeFigureOut">
               <a:rPr lang="en-US" smtClean="0"/>
               <a:t>10/29/2026</a:t>
             </a:fld>
@@ -355,7 +360,7 @@
             </a:lvl1pPr>
           </a:lstStyle>
           <a:p>
-            <a:fld id="{65BC1F6D-F455-4D23-ABC5-6F0DD556C6CF}" type="slidenum">
+            <a:fld id="{A21EF6FC-1F76-4FC5-8D23-56D018858ECA}" type="slidenum">
               <a:rPr lang="en-US" smtClean="0"/>
               <a:t>‹#›</a:t>
             </a:fld>
@@ -366,7 +371,7 @@
     </p:spTree>
     <p:extLst>
       <p:ext uri="{BB962C8B-B14F-4D97-AF65-F5344CB8AC3E}">
-        <p14:creationId xmlns:p14="http://schemas.microsoft.com/office/powerpoint/2010/main" val="2958504550"/>
+        <p14:creationId xmlns:p14="http://schemas.microsoft.com/office/powerpoint/2010/main" val="2508163914"/>
       </p:ext>
     </p:extLst>
   </p:cSld>
@@ -510,10 +515,6 @@
           <a:bodyPr/>
           <a:lstStyle/>
           <a:p>
-            <a:r>
-              <a:rPr lang="fr-FR" smtClean="0"/>
-              <a:t>Le dépôt réel est eventsProject. Tache est un enum, pas une entité de tâches. Cette présentation couvre uniquement le diagnostic déjà exécuté. Les opérations métier et la chaîne CI/CD restent à réaliser.</a:t>
-            </a:r>
             <a:endParaRPr lang="en-US"/>
           </a:p>
         </p:txBody>
@@ -533,7 +534,7 @@
           <a:bodyPr/>
           <a:lstStyle/>
           <a:p>
-            <a:fld id="{65BC1F6D-F455-4D23-ABC5-6F0DD556C6CF}" type="slidenum">
+            <a:fld id="{A21EF6FC-1F76-4FC5-8D23-56D018858ECA}" type="slidenum">
               <a:rPr lang="en-US" smtClean="0"/>
               <a:t>1</a:t>
             </a:fld>
@@ -544,7 +545,259 @@
     </p:spTree>
     <p:extLst>
       <p:ext uri="{BB962C8B-B14F-4D97-AF65-F5344CB8AC3E}">
-        <p14:creationId xmlns:p14="http://schemas.microsoft.com/office/powerpoint/2010/main" val="2891562481"/>
+        <p14:creationId xmlns:p14="http://schemas.microsoft.com/office/powerpoint/2010/main" val="3253090668"/>
+      </p:ext>
+    </p:extLst>
+  </p:cSld>
+  <p:clrMapOvr>
+    <a:masterClrMapping/>
+  </p:clrMapOvr>
+</p:notes>
+</file>
+
+<file path=ppt/notesSlides/notesSlide10.xml><?xml version="1.0" encoding="utf-8"?>
+<p:notes xmlns:a="http://schemas.openxmlformats.org/drawingml/2006/main" xmlns:r="http://schemas.openxmlformats.org/officeDocument/2006/relationships" xmlns:p="http://schemas.openxmlformats.org/presentationml/2006/main">
+  <p:cSld>
+    <p:spTree>
+      <p:nvGrpSpPr>
+        <p:cNvPr id="1" name=""/>
+        <p:cNvGrpSpPr/>
+        <p:nvPr/>
+      </p:nvGrpSpPr>
+      <p:grpSpPr>
+        <a:xfrm>
+          <a:off x="0" y="0"/>
+          <a:ext cx="0" cy="0"/>
+          <a:chOff x="0" y="0"/>
+          <a:chExt cx="0" cy="0"/>
+        </a:xfrm>
+      </p:grpSpPr>
+      <p:sp>
+        <p:nvSpPr>
+          <p:cNvPr id="2" name="Slide Image Placeholder 1"/>
+          <p:cNvSpPr>
+            <a:spLocks noGrp="1" noRot="1" noChangeAspect="1"/>
+          </p:cNvSpPr>
+          <p:nvPr>
+            <p:ph type="sldImg"/>
+          </p:nvPr>
+        </p:nvSpPr>
+        <p:spPr/>
+      </p:sp>
+      <p:sp>
+        <p:nvSpPr>
+          <p:cNvPr id="3" name="Notes Placeholder 2"/>
+          <p:cNvSpPr>
+            <a:spLocks noGrp="1"/>
+          </p:cNvSpPr>
+          <p:nvPr>
+            <p:ph type="body" idx="1"/>
+          </p:nvPr>
+        </p:nvSpPr>
+        <p:spPr/>
+        <p:txBody>
+          <a:bodyPr/>
+          <a:lstStyle/>
+          <a:p>
+            <a:endParaRPr lang="en-US"/>
+          </a:p>
+        </p:txBody>
+      </p:sp>
+      <p:sp>
+        <p:nvSpPr>
+          <p:cNvPr id="4" name="Slide Number Placeholder 3"/>
+          <p:cNvSpPr>
+            <a:spLocks noGrp="1"/>
+          </p:cNvSpPr>
+          <p:nvPr>
+            <p:ph type="sldNum" sz="quarter" idx="10"/>
+          </p:nvPr>
+        </p:nvSpPr>
+        <p:spPr/>
+        <p:txBody>
+          <a:bodyPr/>
+          <a:lstStyle/>
+          <a:p>
+            <a:fld id="{A21EF6FC-1F76-4FC5-8D23-56D018858ECA}" type="slidenum">
+              <a:rPr lang="en-US" smtClean="0"/>
+              <a:t>10</a:t>
+            </a:fld>
+            <a:endParaRPr lang="en-US"/>
+          </a:p>
+        </p:txBody>
+      </p:sp>
+    </p:spTree>
+    <p:extLst>
+      <p:ext uri="{BB962C8B-B14F-4D97-AF65-F5344CB8AC3E}">
+        <p14:creationId xmlns:p14="http://schemas.microsoft.com/office/powerpoint/2010/main" val="3637371725"/>
+      </p:ext>
+    </p:extLst>
+  </p:cSld>
+  <p:clrMapOvr>
+    <a:masterClrMapping/>
+  </p:clrMapOvr>
+</p:notes>
+</file>
+
+<file path=ppt/notesSlides/notesSlide11.xml><?xml version="1.0" encoding="utf-8"?>
+<p:notes xmlns:a="http://schemas.openxmlformats.org/drawingml/2006/main" xmlns:r="http://schemas.openxmlformats.org/officeDocument/2006/relationships" xmlns:p="http://schemas.openxmlformats.org/presentationml/2006/main">
+  <p:cSld>
+    <p:spTree>
+      <p:nvGrpSpPr>
+        <p:cNvPr id="1" name=""/>
+        <p:cNvGrpSpPr/>
+        <p:nvPr/>
+      </p:nvGrpSpPr>
+      <p:grpSpPr>
+        <a:xfrm>
+          <a:off x="0" y="0"/>
+          <a:ext cx="0" cy="0"/>
+          <a:chOff x="0" y="0"/>
+          <a:chExt cx="0" cy="0"/>
+        </a:xfrm>
+      </p:grpSpPr>
+      <p:sp>
+        <p:nvSpPr>
+          <p:cNvPr id="2" name="Slide Image Placeholder 1"/>
+          <p:cNvSpPr>
+            <a:spLocks noGrp="1" noRot="1" noChangeAspect="1"/>
+          </p:cNvSpPr>
+          <p:nvPr>
+            <p:ph type="sldImg"/>
+          </p:nvPr>
+        </p:nvSpPr>
+        <p:spPr/>
+      </p:sp>
+      <p:sp>
+        <p:nvSpPr>
+          <p:cNvPr id="3" name="Notes Placeholder 2"/>
+          <p:cNvSpPr>
+            <a:spLocks noGrp="1"/>
+          </p:cNvSpPr>
+          <p:nvPr>
+            <p:ph type="body" idx="1"/>
+          </p:nvPr>
+        </p:nvSpPr>
+        <p:spPr/>
+        <p:txBody>
+          <a:bodyPr/>
+          <a:lstStyle/>
+          <a:p>
+            <a:endParaRPr lang="en-US"/>
+          </a:p>
+        </p:txBody>
+      </p:sp>
+      <p:sp>
+        <p:nvSpPr>
+          <p:cNvPr id="4" name="Slide Number Placeholder 3"/>
+          <p:cNvSpPr>
+            <a:spLocks noGrp="1"/>
+          </p:cNvSpPr>
+          <p:nvPr>
+            <p:ph type="sldNum" sz="quarter" idx="10"/>
+          </p:nvPr>
+        </p:nvSpPr>
+        <p:spPr/>
+        <p:txBody>
+          <a:bodyPr/>
+          <a:lstStyle/>
+          <a:p>
+            <a:fld id="{A21EF6FC-1F76-4FC5-8D23-56D018858ECA}" type="slidenum">
+              <a:rPr lang="en-US" smtClean="0"/>
+              <a:t>11</a:t>
+            </a:fld>
+            <a:endParaRPr lang="en-US"/>
+          </a:p>
+        </p:txBody>
+      </p:sp>
+    </p:spTree>
+    <p:extLst>
+      <p:ext uri="{BB962C8B-B14F-4D97-AF65-F5344CB8AC3E}">
+        <p14:creationId xmlns:p14="http://schemas.microsoft.com/office/powerpoint/2010/main" val="4230160122"/>
+      </p:ext>
+    </p:extLst>
+  </p:cSld>
+  <p:clrMapOvr>
+    <a:masterClrMapping/>
+  </p:clrMapOvr>
+</p:notes>
+</file>
+
+<file path=ppt/notesSlides/notesSlide12.xml><?xml version="1.0" encoding="utf-8"?>
+<p:notes xmlns:a="http://schemas.openxmlformats.org/drawingml/2006/main" xmlns:r="http://schemas.openxmlformats.org/officeDocument/2006/relationships" xmlns:p="http://schemas.openxmlformats.org/presentationml/2006/main">
+  <p:cSld>
+    <p:spTree>
+      <p:nvGrpSpPr>
+        <p:cNvPr id="1" name=""/>
+        <p:cNvGrpSpPr/>
+        <p:nvPr/>
+      </p:nvGrpSpPr>
+      <p:grpSpPr>
+        <a:xfrm>
+          <a:off x="0" y="0"/>
+          <a:ext cx="0" cy="0"/>
+          <a:chOff x="0" y="0"/>
+          <a:chExt cx="0" cy="0"/>
+        </a:xfrm>
+      </p:grpSpPr>
+      <p:sp>
+        <p:nvSpPr>
+          <p:cNvPr id="2" name="Slide Image Placeholder 1"/>
+          <p:cNvSpPr>
+            <a:spLocks noGrp="1" noRot="1" noChangeAspect="1"/>
+          </p:cNvSpPr>
+          <p:nvPr>
+            <p:ph type="sldImg"/>
+          </p:nvPr>
+        </p:nvSpPr>
+        <p:spPr/>
+      </p:sp>
+      <p:sp>
+        <p:nvSpPr>
+          <p:cNvPr id="3" name="Notes Placeholder 2"/>
+          <p:cNvSpPr>
+            <a:spLocks noGrp="1"/>
+          </p:cNvSpPr>
+          <p:nvPr>
+            <p:ph type="body" idx="1"/>
+          </p:nvPr>
+        </p:nvSpPr>
+        <p:spPr/>
+        <p:txBody>
+          <a:bodyPr/>
+          <a:lstStyle/>
+          <a:p>
+            <a:endParaRPr lang="en-US"/>
+          </a:p>
+        </p:txBody>
+      </p:sp>
+      <p:sp>
+        <p:nvSpPr>
+          <p:cNvPr id="4" name="Slide Number Placeholder 3"/>
+          <p:cNvSpPr>
+            <a:spLocks noGrp="1"/>
+          </p:cNvSpPr>
+          <p:nvPr>
+            <p:ph type="sldNum" sz="quarter" idx="10"/>
+          </p:nvPr>
+        </p:nvSpPr>
+        <p:spPr/>
+        <p:txBody>
+          <a:bodyPr/>
+          <a:lstStyle/>
+          <a:p>
+            <a:fld id="{A21EF6FC-1F76-4FC5-8D23-56D018858ECA}" type="slidenum">
+              <a:rPr lang="en-US" smtClean="0"/>
+              <a:t>12</a:t>
+            </a:fld>
+            <a:endParaRPr lang="en-US"/>
+          </a:p>
+        </p:txBody>
+      </p:sp>
+    </p:spTree>
+    <p:extLst>
+      <p:ext uri="{BB962C8B-B14F-4D97-AF65-F5344CB8AC3E}">
+        <p14:creationId xmlns:p14="http://schemas.microsoft.com/office/powerpoint/2010/main" val="1054782567"/>
       </p:ext>
     </p:extLst>
   </p:cSld>
@@ -598,10 +851,6 @@
           <a:bodyPr/>
           <a:lstStyle/>
           <a:p>
-            <a:r>
-              <a:rPr lang="fr-FR" smtClean="0"/>
-              <a:t>Source actuelle affichée dans un visualiseur Windows puis capturée à l'écran. @Enumerated(EnumType.STRING) conserve le nom de la valeur dans la base. Renommer une valeur impose de considérer les données existantes. Aucune nouvelle logique métier n'a encore été ajoutée.</a:t>
-            </a:r>
             <a:endParaRPr lang="en-US"/>
           </a:p>
         </p:txBody>
@@ -621,7 +870,7 @@
           <a:bodyPr/>
           <a:lstStyle/>
           <a:p>
-            <a:fld id="{65BC1F6D-F455-4D23-ABC5-6F0DD556C6CF}" type="slidenum">
+            <a:fld id="{A21EF6FC-1F76-4FC5-8D23-56D018858ECA}" type="slidenum">
               <a:rPr lang="en-US" smtClean="0"/>
               <a:t>2</a:t>
             </a:fld>
@@ -632,7 +881,7 @@
     </p:spTree>
     <p:extLst>
       <p:ext uri="{BB962C8B-B14F-4D97-AF65-F5344CB8AC3E}">
-        <p14:creationId xmlns:p14="http://schemas.microsoft.com/office/powerpoint/2010/main" val="1361608691"/>
+        <p14:creationId xmlns:p14="http://schemas.microsoft.com/office/powerpoint/2010/main" val="2976288885"/>
       </p:ext>
     </p:extLst>
   </p:cSld>
@@ -686,10 +935,6 @@
           <a:bodyPr/>
           <a:lstStyle/>
           <a:p>
-            <a:r>
-              <a:rPr lang="fr-FR" smtClean="0"/>
-              <a:t>Les commandes Git ont été exécutées lors de la capture. Le commit de diagnostic ajoute la documentation et les journaux. La branche distante Tache était absente lors de l'inspection initiale. Cela ne démontre pas encore un Git Flow complet.</a:t>
-            </a:r>
             <a:endParaRPr lang="en-US"/>
           </a:p>
         </p:txBody>
@@ -709,7 +954,7 @@
           <a:bodyPr/>
           <a:lstStyle/>
           <a:p>
-            <a:fld id="{65BC1F6D-F455-4D23-ABC5-6F0DD556C6CF}" type="slidenum">
+            <a:fld id="{A21EF6FC-1F76-4FC5-8D23-56D018858ECA}" type="slidenum">
               <a:rPr lang="en-US" smtClean="0"/>
               <a:t>3</a:t>
             </a:fld>
@@ -720,7 +965,7 @@
     </p:spTree>
     <p:extLst>
       <p:ext uri="{BB962C8B-B14F-4D97-AF65-F5344CB8AC3E}">
-        <p14:creationId xmlns:p14="http://schemas.microsoft.com/office/powerpoint/2010/main" val="1181752981"/>
+        <p14:creationId xmlns:p14="http://schemas.microsoft.com/office/powerpoint/2010/main" val="4105230027"/>
       </p:ext>
     </p:extLst>
   </p:cSld>
@@ -774,10 +1019,6 @@
           <a:bodyPr/>
           <a:lstStyle/>
           <a:p>
-            <a:r>
-              <a:rPr lang="fr-FR" smtClean="0"/>
-              <a:t>Commande exécutée au moment de la capture. Maven était déjà installé dans le cache mais absent du PATH. Le script modifie JAVA_HOME et PATH pour la session uniquement. Java 8 correspond à la cible du POM ; ce JDK ancien sert au diagnostic local.</a:t>
-            </a:r>
             <a:endParaRPr lang="en-US"/>
           </a:p>
         </p:txBody>
@@ -797,7 +1038,7 @@
           <a:bodyPr/>
           <a:lstStyle/>
           <a:p>
-            <a:fld id="{65BC1F6D-F455-4D23-ABC5-6F0DD556C6CF}" type="slidenum">
+            <a:fld id="{A21EF6FC-1F76-4FC5-8D23-56D018858ECA}" type="slidenum">
               <a:rPr lang="en-US" smtClean="0"/>
               <a:t>4</a:t>
             </a:fld>
@@ -808,7 +1049,7 @@
     </p:spTree>
     <p:extLst>
       <p:ext uri="{BB962C8B-B14F-4D97-AF65-F5344CB8AC3E}">
-        <p14:creationId xmlns:p14="http://schemas.microsoft.com/office/powerpoint/2010/main" val="2405248658"/>
+        <p14:creationId xmlns:p14="http://schemas.microsoft.com/office/powerpoint/2010/main" val="1850392566"/>
       </p:ext>
     </p:extLst>
   </p:cSld>
@@ -862,10 +1103,6 @@
           <a:bodyPr/>
           <a:lstStyle/>
           <a:p>
-            <a:r>
-              <a:rPr lang="fr-FR" smtClean="0"/>
-              <a:t>Capture de la lecture du journal sauvegardé de mvn -B compile. Ce n'est pas une nouvelle compilation au moment de la capture. BUILD SUCCESS prouve la compilation, pas les tests, la connexion JDBC ou le fonctionnement métier. Aucun test n'existait dans le dépôt initial.</a:t>
-            </a:r>
             <a:endParaRPr lang="en-US"/>
           </a:p>
         </p:txBody>
@@ -885,7 +1122,7 @@
           <a:bodyPr/>
           <a:lstStyle/>
           <a:p>
-            <a:fld id="{65BC1F6D-F455-4D23-ABC5-6F0DD556C6CF}" type="slidenum">
+            <a:fld id="{A21EF6FC-1F76-4FC5-8D23-56D018858ECA}" type="slidenum">
               <a:rPr lang="en-US" smtClean="0"/>
               <a:t>5</a:t>
             </a:fld>
@@ -896,7 +1133,7 @@
     </p:spTree>
     <p:extLst>
       <p:ext uri="{BB962C8B-B14F-4D97-AF65-F5344CB8AC3E}">
-        <p14:creationId xmlns:p14="http://schemas.microsoft.com/office/powerpoint/2010/main" val="2450517872"/>
+        <p14:creationId xmlns:p14="http://schemas.microsoft.com/office/powerpoint/2010/main" val="2766151398"/>
       </p:ext>
     </p:extLst>
   </p:cSld>
@@ -950,10 +1187,6 @@
           <a:bodyPr/>
           <a:lstStyle/>
           <a:p>
-            <a:r>
-              <a:rPr lang="fr-FR" smtClean="0"/>
-              <a:t>Capture de journaux sauvegardés pendant le diagnostic. Le démarrage utilisait ddl-auto=none et désactivait la création automatique de base. Le serveur existant refuse root sans mot de passe. Solution prévue : base dédiée et configuration par environnement, encore non appliquée.</a:t>
-            </a:r>
             <a:endParaRPr lang="en-US"/>
           </a:p>
         </p:txBody>
@@ -973,7 +1206,7 @@
           <a:bodyPr/>
           <a:lstStyle/>
           <a:p>
-            <a:fld id="{65BC1F6D-F455-4D23-ABC5-6F0DD556C6CF}" type="slidenum">
+            <a:fld id="{A21EF6FC-1F76-4FC5-8D23-56D018858ECA}" type="slidenum">
               <a:rPr lang="en-US" smtClean="0"/>
               <a:t>6</a:t>
             </a:fld>
@@ -984,7 +1217,7 @@
     </p:spTree>
     <p:extLst>
       <p:ext uri="{BB962C8B-B14F-4D97-AF65-F5344CB8AC3E}">
-        <p14:creationId xmlns:p14="http://schemas.microsoft.com/office/powerpoint/2010/main" val="336723368"/>
+        <p14:creationId xmlns:p14="http://schemas.microsoft.com/office/powerpoint/2010/main" val="1986542302"/>
       </p:ext>
     </p:extLst>
   </p:cSld>
@@ -1038,10 +1271,6 @@
           <a:bodyPr/>
           <a:lstStyle/>
           <a:p>
-            <a:r>
-              <a:rPr lang="fr-FR" smtClean="0"/>
-              <a:t>Le fonctionnement métier reste bloqué. Priorité suivante : base MySQL dédiée, requête API réelle, puis service de rôles et tests. Jenkins, SonarQube, Nexus, Docker applicatif, Kubernetes, Terraform et monitoring ne sont pas encore démontrés. Terraform apply exige la revue du plan et l'accord utilisateur.</a:t>
-            </a:r>
             <a:endParaRPr lang="en-US"/>
           </a:p>
         </p:txBody>
@@ -1061,7 +1290,7 @@
           <a:bodyPr/>
           <a:lstStyle/>
           <a:p>
-            <a:fld id="{65BC1F6D-F455-4D23-ABC5-6F0DD556C6CF}" type="slidenum">
+            <a:fld id="{A21EF6FC-1F76-4FC5-8D23-56D018858ECA}" type="slidenum">
               <a:rPr lang="en-US" smtClean="0"/>
               <a:t>7</a:t>
             </a:fld>
@@ -1072,7 +1301,175 @@
     </p:spTree>
     <p:extLst>
       <p:ext uri="{BB962C8B-B14F-4D97-AF65-F5344CB8AC3E}">
-        <p14:creationId xmlns:p14="http://schemas.microsoft.com/office/powerpoint/2010/main" val="116990167"/>
+        <p14:creationId xmlns:p14="http://schemas.microsoft.com/office/powerpoint/2010/main" val="3402579424"/>
+      </p:ext>
+    </p:extLst>
+  </p:cSld>
+  <p:clrMapOvr>
+    <a:masterClrMapping/>
+  </p:clrMapOvr>
+</p:notes>
+</file>
+
+<file path=ppt/notesSlides/notesSlide8.xml><?xml version="1.0" encoding="utf-8"?>
+<p:notes xmlns:a="http://schemas.openxmlformats.org/drawingml/2006/main" xmlns:r="http://schemas.openxmlformats.org/officeDocument/2006/relationships" xmlns:p="http://schemas.openxmlformats.org/presentationml/2006/main">
+  <p:cSld>
+    <p:spTree>
+      <p:nvGrpSpPr>
+        <p:cNvPr id="1" name=""/>
+        <p:cNvGrpSpPr/>
+        <p:nvPr/>
+      </p:nvGrpSpPr>
+      <p:grpSpPr>
+        <a:xfrm>
+          <a:off x="0" y="0"/>
+          <a:ext cx="0" cy="0"/>
+          <a:chOff x="0" y="0"/>
+          <a:chExt cx="0" cy="0"/>
+        </a:xfrm>
+      </p:grpSpPr>
+      <p:sp>
+        <p:nvSpPr>
+          <p:cNvPr id="2" name="Slide Image Placeholder 1"/>
+          <p:cNvSpPr>
+            <a:spLocks noGrp="1" noRot="1" noChangeAspect="1"/>
+          </p:cNvSpPr>
+          <p:nvPr>
+            <p:ph type="sldImg"/>
+          </p:nvPr>
+        </p:nvSpPr>
+        <p:spPr/>
+      </p:sp>
+      <p:sp>
+        <p:nvSpPr>
+          <p:cNvPr id="3" name="Notes Placeholder 2"/>
+          <p:cNvSpPr>
+            <a:spLocks noGrp="1"/>
+          </p:cNvSpPr>
+          <p:nvPr>
+            <p:ph type="body" idx="1"/>
+          </p:nvPr>
+        </p:nvSpPr>
+        <p:spPr/>
+        <p:txBody>
+          <a:bodyPr/>
+          <a:lstStyle/>
+          <a:p>
+            <a:endParaRPr lang="en-US"/>
+          </a:p>
+        </p:txBody>
+      </p:sp>
+      <p:sp>
+        <p:nvSpPr>
+          <p:cNvPr id="4" name="Slide Number Placeholder 3"/>
+          <p:cNvSpPr>
+            <a:spLocks noGrp="1"/>
+          </p:cNvSpPr>
+          <p:nvPr>
+            <p:ph type="sldNum" sz="quarter" idx="10"/>
+          </p:nvPr>
+        </p:nvSpPr>
+        <p:spPr/>
+        <p:txBody>
+          <a:bodyPr/>
+          <a:lstStyle/>
+          <a:p>
+            <a:fld id="{A21EF6FC-1F76-4FC5-8D23-56D018858ECA}" type="slidenum">
+              <a:rPr lang="en-US" smtClean="0"/>
+              <a:t>8</a:t>
+            </a:fld>
+            <a:endParaRPr lang="en-US"/>
+          </a:p>
+        </p:txBody>
+      </p:sp>
+    </p:spTree>
+    <p:extLst>
+      <p:ext uri="{BB962C8B-B14F-4D97-AF65-F5344CB8AC3E}">
+        <p14:creationId xmlns:p14="http://schemas.microsoft.com/office/powerpoint/2010/main" val="2736300699"/>
+      </p:ext>
+    </p:extLst>
+  </p:cSld>
+  <p:clrMapOvr>
+    <a:masterClrMapping/>
+  </p:clrMapOvr>
+</p:notes>
+</file>
+
+<file path=ppt/notesSlides/notesSlide9.xml><?xml version="1.0" encoding="utf-8"?>
+<p:notes xmlns:a="http://schemas.openxmlformats.org/drawingml/2006/main" xmlns:r="http://schemas.openxmlformats.org/officeDocument/2006/relationships" xmlns:p="http://schemas.openxmlformats.org/presentationml/2006/main">
+  <p:cSld>
+    <p:spTree>
+      <p:nvGrpSpPr>
+        <p:cNvPr id="1" name=""/>
+        <p:cNvGrpSpPr/>
+        <p:nvPr/>
+      </p:nvGrpSpPr>
+      <p:grpSpPr>
+        <a:xfrm>
+          <a:off x="0" y="0"/>
+          <a:ext cx="0" cy="0"/>
+          <a:chOff x="0" y="0"/>
+          <a:chExt cx="0" cy="0"/>
+        </a:xfrm>
+      </p:grpSpPr>
+      <p:sp>
+        <p:nvSpPr>
+          <p:cNvPr id="2" name="Slide Image Placeholder 1"/>
+          <p:cNvSpPr>
+            <a:spLocks noGrp="1" noRot="1" noChangeAspect="1"/>
+          </p:cNvSpPr>
+          <p:nvPr>
+            <p:ph type="sldImg"/>
+          </p:nvPr>
+        </p:nvSpPr>
+        <p:spPr/>
+      </p:sp>
+      <p:sp>
+        <p:nvSpPr>
+          <p:cNvPr id="3" name="Notes Placeholder 2"/>
+          <p:cNvSpPr>
+            <a:spLocks noGrp="1"/>
+          </p:cNvSpPr>
+          <p:nvPr>
+            <p:ph type="body" idx="1"/>
+          </p:nvPr>
+        </p:nvSpPr>
+        <p:spPr/>
+        <p:txBody>
+          <a:bodyPr/>
+          <a:lstStyle/>
+          <a:p>
+            <a:endParaRPr lang="en-US"/>
+          </a:p>
+        </p:txBody>
+      </p:sp>
+      <p:sp>
+        <p:nvSpPr>
+          <p:cNvPr id="4" name="Slide Number Placeholder 3"/>
+          <p:cNvSpPr>
+            <a:spLocks noGrp="1"/>
+          </p:cNvSpPr>
+          <p:nvPr>
+            <p:ph type="sldNum" sz="quarter" idx="10"/>
+          </p:nvPr>
+        </p:nvSpPr>
+        <p:spPr/>
+        <p:txBody>
+          <a:bodyPr/>
+          <a:lstStyle/>
+          <a:p>
+            <a:fld id="{A21EF6FC-1F76-4FC5-8D23-56D018858ECA}" type="slidenum">
+              <a:rPr lang="en-US" smtClean="0"/>
+              <a:t>9</a:t>
+            </a:fld>
+            <a:endParaRPr lang="en-US"/>
+          </a:p>
+        </p:txBody>
+      </p:sp>
+    </p:spTree>
+    <p:extLst>
+      <p:ext uri="{BB962C8B-B14F-4D97-AF65-F5344CB8AC3E}">
+        <p14:creationId xmlns:p14="http://schemas.microsoft.com/office/powerpoint/2010/main" val="670895476"/>
       </p:ext>
     </p:extLst>
   </p:cSld>
@@ -1211,7 +1608,7 @@
           <a:bodyPr/>
           <a:lstStyle/>
           <a:p>
-            <a:fld id="{6D433DB6-1AED-4A33-8C9C-751A29CD9F6D}" type="datetimeFigureOut">
+            <a:fld id="{2799EB36-BA8B-4EA3-8503-D9B03E23417C}" type="datetimeFigureOut">
               <a:rPr lang="en-US" smtClean="0"/>
               <a:t>10/29/2026</a:t>
             </a:fld>
@@ -1253,7 +1650,7 @@
           <a:bodyPr/>
           <a:lstStyle/>
           <a:p>
-            <a:fld id="{7EB76E00-5A08-439C-95EF-3524E9C729DA}" type="slidenum">
+            <a:fld id="{5704788F-762F-4466-8534-F2D60E916612}" type="slidenum">
               <a:rPr lang="en-US" smtClean="0"/>
               <a:t>‹#›</a:t>
             </a:fld>
@@ -1264,7 +1661,7 @@
     </p:spTree>
     <p:extLst>
       <p:ext uri="{BB962C8B-B14F-4D97-AF65-F5344CB8AC3E}">
-        <p14:creationId xmlns:p14="http://schemas.microsoft.com/office/powerpoint/2010/main" val="1669547909"/>
+        <p14:creationId xmlns:p14="http://schemas.microsoft.com/office/powerpoint/2010/main" val="1706178020"/>
       </p:ext>
     </p:extLst>
   </p:cSld>
@@ -1381,7 +1778,7 @@
           <a:bodyPr/>
           <a:lstStyle/>
           <a:p>
-            <a:fld id="{6D433DB6-1AED-4A33-8C9C-751A29CD9F6D}" type="datetimeFigureOut">
+            <a:fld id="{2799EB36-BA8B-4EA3-8503-D9B03E23417C}" type="datetimeFigureOut">
               <a:rPr lang="en-US" smtClean="0"/>
               <a:t>10/29/2026</a:t>
             </a:fld>
@@ -1423,7 +1820,7 @@
           <a:bodyPr/>
           <a:lstStyle/>
           <a:p>
-            <a:fld id="{7EB76E00-5A08-439C-95EF-3524E9C729DA}" type="slidenum">
+            <a:fld id="{5704788F-762F-4466-8534-F2D60E916612}" type="slidenum">
               <a:rPr lang="en-US" smtClean="0"/>
               <a:t>‹#›</a:t>
             </a:fld>
@@ -1434,7 +1831,7 @@
     </p:spTree>
     <p:extLst>
       <p:ext uri="{BB962C8B-B14F-4D97-AF65-F5344CB8AC3E}">
-        <p14:creationId xmlns:p14="http://schemas.microsoft.com/office/powerpoint/2010/main" val="921652759"/>
+        <p14:creationId xmlns:p14="http://schemas.microsoft.com/office/powerpoint/2010/main" val="2921330052"/>
       </p:ext>
     </p:extLst>
   </p:cSld>
@@ -1561,7 +1958,7 @@
           <a:bodyPr/>
           <a:lstStyle/>
           <a:p>
-            <a:fld id="{6D433DB6-1AED-4A33-8C9C-751A29CD9F6D}" type="datetimeFigureOut">
+            <a:fld id="{2799EB36-BA8B-4EA3-8503-D9B03E23417C}" type="datetimeFigureOut">
               <a:rPr lang="en-US" smtClean="0"/>
               <a:t>10/29/2026</a:t>
             </a:fld>
@@ -1603,7 +2000,7 @@
           <a:bodyPr/>
           <a:lstStyle/>
           <a:p>
-            <a:fld id="{7EB76E00-5A08-439C-95EF-3524E9C729DA}" type="slidenum">
+            <a:fld id="{5704788F-762F-4466-8534-F2D60E916612}" type="slidenum">
               <a:rPr lang="en-US" smtClean="0"/>
               <a:t>‹#›</a:t>
             </a:fld>
@@ -1614,7 +2011,7 @@
     </p:spTree>
     <p:extLst>
       <p:ext uri="{BB962C8B-B14F-4D97-AF65-F5344CB8AC3E}">
-        <p14:creationId xmlns:p14="http://schemas.microsoft.com/office/powerpoint/2010/main" val="2260784687"/>
+        <p14:creationId xmlns:p14="http://schemas.microsoft.com/office/powerpoint/2010/main" val="680015534"/>
       </p:ext>
     </p:extLst>
   </p:cSld>
@@ -1731,7 +2128,7 @@
           <a:bodyPr/>
           <a:lstStyle/>
           <a:p>
-            <a:fld id="{6D433DB6-1AED-4A33-8C9C-751A29CD9F6D}" type="datetimeFigureOut">
+            <a:fld id="{2799EB36-BA8B-4EA3-8503-D9B03E23417C}" type="datetimeFigureOut">
               <a:rPr lang="en-US" smtClean="0"/>
               <a:t>10/29/2026</a:t>
             </a:fld>
@@ -1773,7 +2170,7 @@
           <a:bodyPr/>
           <a:lstStyle/>
           <a:p>
-            <a:fld id="{7EB76E00-5A08-439C-95EF-3524E9C729DA}" type="slidenum">
+            <a:fld id="{5704788F-762F-4466-8534-F2D60E916612}" type="slidenum">
               <a:rPr lang="en-US" smtClean="0"/>
               <a:t>‹#›</a:t>
             </a:fld>
@@ -1784,7 +2181,7 @@
     </p:spTree>
     <p:extLst>
       <p:ext uri="{BB962C8B-B14F-4D97-AF65-F5344CB8AC3E}">
-        <p14:creationId xmlns:p14="http://schemas.microsoft.com/office/powerpoint/2010/main" val="140242495"/>
+        <p14:creationId xmlns:p14="http://schemas.microsoft.com/office/powerpoint/2010/main" val="743727867"/>
       </p:ext>
     </p:extLst>
   </p:cSld>
@@ -1977,7 +2374,7 @@
           <a:bodyPr/>
           <a:lstStyle/>
           <a:p>
-            <a:fld id="{6D433DB6-1AED-4A33-8C9C-751A29CD9F6D}" type="datetimeFigureOut">
+            <a:fld id="{2799EB36-BA8B-4EA3-8503-D9B03E23417C}" type="datetimeFigureOut">
               <a:rPr lang="en-US" smtClean="0"/>
               <a:t>10/29/2026</a:t>
             </a:fld>
@@ -2019,7 +2416,7 @@
           <a:bodyPr/>
           <a:lstStyle/>
           <a:p>
-            <a:fld id="{7EB76E00-5A08-439C-95EF-3524E9C729DA}" type="slidenum">
+            <a:fld id="{5704788F-762F-4466-8534-F2D60E916612}" type="slidenum">
               <a:rPr lang="en-US" smtClean="0"/>
               <a:t>‹#›</a:t>
             </a:fld>
@@ -2030,7 +2427,7 @@
     </p:spTree>
     <p:extLst>
       <p:ext uri="{BB962C8B-B14F-4D97-AF65-F5344CB8AC3E}">
-        <p14:creationId xmlns:p14="http://schemas.microsoft.com/office/powerpoint/2010/main" val="631284490"/>
+        <p14:creationId xmlns:p14="http://schemas.microsoft.com/office/powerpoint/2010/main" val="4273814727"/>
       </p:ext>
     </p:extLst>
   </p:cSld>
@@ -2209,7 +2606,7 @@
           <a:bodyPr/>
           <a:lstStyle/>
           <a:p>
-            <a:fld id="{6D433DB6-1AED-4A33-8C9C-751A29CD9F6D}" type="datetimeFigureOut">
+            <a:fld id="{2799EB36-BA8B-4EA3-8503-D9B03E23417C}" type="datetimeFigureOut">
               <a:rPr lang="en-US" smtClean="0"/>
               <a:t>10/29/2026</a:t>
             </a:fld>
@@ -2251,7 +2648,7 @@
           <a:bodyPr/>
           <a:lstStyle/>
           <a:p>
-            <a:fld id="{7EB76E00-5A08-439C-95EF-3524E9C729DA}" type="slidenum">
+            <a:fld id="{5704788F-762F-4466-8534-F2D60E916612}" type="slidenum">
               <a:rPr lang="en-US" smtClean="0"/>
               <a:t>‹#›</a:t>
             </a:fld>
@@ -2262,7 +2659,7 @@
     </p:spTree>
     <p:extLst>
       <p:ext uri="{BB962C8B-B14F-4D97-AF65-F5344CB8AC3E}">
-        <p14:creationId xmlns:p14="http://schemas.microsoft.com/office/powerpoint/2010/main" val="2110435961"/>
+        <p14:creationId xmlns:p14="http://schemas.microsoft.com/office/powerpoint/2010/main" val="3465418760"/>
       </p:ext>
     </p:extLst>
   </p:cSld>
@@ -2576,7 +2973,7 @@
           <a:bodyPr/>
           <a:lstStyle/>
           <a:p>
-            <a:fld id="{6D433DB6-1AED-4A33-8C9C-751A29CD9F6D}" type="datetimeFigureOut">
+            <a:fld id="{2799EB36-BA8B-4EA3-8503-D9B03E23417C}" type="datetimeFigureOut">
               <a:rPr lang="en-US" smtClean="0"/>
               <a:t>10/29/2026</a:t>
             </a:fld>
@@ -2618,7 +3015,7 @@
           <a:bodyPr/>
           <a:lstStyle/>
           <a:p>
-            <a:fld id="{7EB76E00-5A08-439C-95EF-3524E9C729DA}" type="slidenum">
+            <a:fld id="{5704788F-762F-4466-8534-F2D60E916612}" type="slidenum">
               <a:rPr lang="en-US" smtClean="0"/>
               <a:t>‹#›</a:t>
             </a:fld>
@@ -2629,7 +3026,7 @@
     </p:spTree>
     <p:extLst>
       <p:ext uri="{BB962C8B-B14F-4D97-AF65-F5344CB8AC3E}">
-        <p14:creationId xmlns:p14="http://schemas.microsoft.com/office/powerpoint/2010/main" val="2984367112"/>
+        <p14:creationId xmlns:p14="http://schemas.microsoft.com/office/powerpoint/2010/main" val="3920530259"/>
       </p:ext>
     </p:extLst>
   </p:cSld>
@@ -2694,7 +3091,7 @@
           <a:bodyPr/>
           <a:lstStyle/>
           <a:p>
-            <a:fld id="{6D433DB6-1AED-4A33-8C9C-751A29CD9F6D}" type="datetimeFigureOut">
+            <a:fld id="{2799EB36-BA8B-4EA3-8503-D9B03E23417C}" type="datetimeFigureOut">
               <a:rPr lang="en-US" smtClean="0"/>
               <a:t>10/29/2026</a:t>
             </a:fld>
@@ -2736,7 +3133,7 @@
           <a:bodyPr/>
           <a:lstStyle/>
           <a:p>
-            <a:fld id="{7EB76E00-5A08-439C-95EF-3524E9C729DA}" type="slidenum">
+            <a:fld id="{5704788F-762F-4466-8534-F2D60E916612}" type="slidenum">
               <a:rPr lang="en-US" smtClean="0"/>
               <a:t>‹#›</a:t>
             </a:fld>
@@ -2747,7 +3144,7 @@
     </p:spTree>
     <p:extLst>
       <p:ext uri="{BB962C8B-B14F-4D97-AF65-F5344CB8AC3E}">
-        <p14:creationId xmlns:p14="http://schemas.microsoft.com/office/powerpoint/2010/main" val="1000975128"/>
+        <p14:creationId xmlns:p14="http://schemas.microsoft.com/office/powerpoint/2010/main" val="1010233697"/>
       </p:ext>
     </p:extLst>
   </p:cSld>
@@ -2789,7 +3186,7 @@
           <a:bodyPr/>
           <a:lstStyle/>
           <a:p>
-            <a:fld id="{6D433DB6-1AED-4A33-8C9C-751A29CD9F6D}" type="datetimeFigureOut">
+            <a:fld id="{2799EB36-BA8B-4EA3-8503-D9B03E23417C}" type="datetimeFigureOut">
               <a:rPr lang="en-US" smtClean="0"/>
               <a:t>10/29/2026</a:t>
             </a:fld>
@@ -2831,7 +3228,7 @@
           <a:bodyPr/>
           <a:lstStyle/>
           <a:p>
-            <a:fld id="{7EB76E00-5A08-439C-95EF-3524E9C729DA}" type="slidenum">
+            <a:fld id="{5704788F-762F-4466-8534-F2D60E916612}" type="slidenum">
               <a:rPr lang="en-US" smtClean="0"/>
               <a:t>‹#›</a:t>
             </a:fld>
@@ -2842,7 +3239,7 @@
     </p:spTree>
     <p:extLst>
       <p:ext uri="{BB962C8B-B14F-4D97-AF65-F5344CB8AC3E}">
-        <p14:creationId xmlns:p14="http://schemas.microsoft.com/office/powerpoint/2010/main" val="160748297"/>
+        <p14:creationId xmlns:p14="http://schemas.microsoft.com/office/powerpoint/2010/main" val="1135608108"/>
       </p:ext>
     </p:extLst>
   </p:cSld>
@@ -3066,7 +3463,7 @@
           <a:bodyPr/>
           <a:lstStyle/>
           <a:p>
-            <a:fld id="{6D433DB6-1AED-4A33-8C9C-751A29CD9F6D}" type="datetimeFigureOut">
+            <a:fld id="{2799EB36-BA8B-4EA3-8503-D9B03E23417C}" type="datetimeFigureOut">
               <a:rPr lang="en-US" smtClean="0"/>
               <a:t>10/29/2026</a:t>
             </a:fld>
@@ -3108,7 +3505,7 @@
           <a:bodyPr/>
           <a:lstStyle/>
           <a:p>
-            <a:fld id="{7EB76E00-5A08-439C-95EF-3524E9C729DA}" type="slidenum">
+            <a:fld id="{5704788F-762F-4466-8534-F2D60E916612}" type="slidenum">
               <a:rPr lang="en-US" smtClean="0"/>
               <a:t>‹#›</a:t>
             </a:fld>
@@ -3119,7 +3516,7 @@
     </p:spTree>
     <p:extLst>
       <p:ext uri="{BB962C8B-B14F-4D97-AF65-F5344CB8AC3E}">
-        <p14:creationId xmlns:p14="http://schemas.microsoft.com/office/powerpoint/2010/main" val="2098282309"/>
+        <p14:creationId xmlns:p14="http://schemas.microsoft.com/office/powerpoint/2010/main" val="2207004144"/>
       </p:ext>
     </p:extLst>
   </p:cSld>
@@ -3319,7 +3716,7 @@
           <a:bodyPr/>
           <a:lstStyle/>
           <a:p>
-            <a:fld id="{6D433DB6-1AED-4A33-8C9C-751A29CD9F6D}" type="datetimeFigureOut">
+            <a:fld id="{2799EB36-BA8B-4EA3-8503-D9B03E23417C}" type="datetimeFigureOut">
               <a:rPr lang="en-US" smtClean="0"/>
               <a:t>10/29/2026</a:t>
             </a:fld>
@@ -3361,7 +3758,7 @@
           <a:bodyPr/>
           <a:lstStyle/>
           <a:p>
-            <a:fld id="{7EB76E00-5A08-439C-95EF-3524E9C729DA}" type="slidenum">
+            <a:fld id="{5704788F-762F-4466-8534-F2D60E916612}" type="slidenum">
               <a:rPr lang="en-US" smtClean="0"/>
               <a:t>‹#›</a:t>
             </a:fld>
@@ -3372,7 +3769,7 @@
     </p:spTree>
     <p:extLst>
       <p:ext uri="{BB962C8B-B14F-4D97-AF65-F5344CB8AC3E}">
-        <p14:creationId xmlns:p14="http://schemas.microsoft.com/office/powerpoint/2010/main" val="1096611882"/>
+        <p14:creationId xmlns:p14="http://schemas.microsoft.com/office/powerpoint/2010/main" val="3997334128"/>
       </p:ext>
     </p:extLst>
   </p:cSld>
@@ -3532,7 +3929,7 @@
             </a:lvl1pPr>
           </a:lstStyle>
           <a:p>
-            <a:fld id="{6D433DB6-1AED-4A33-8C9C-751A29CD9F6D}" type="datetimeFigureOut">
+            <a:fld id="{2799EB36-BA8B-4EA3-8503-D9B03E23417C}" type="datetimeFigureOut">
               <a:rPr lang="en-US" smtClean="0"/>
               <a:t>10/29/2026</a:t>
             </a:fld>
@@ -3610,7 +4007,7 @@
             </a:lvl1pPr>
           </a:lstStyle>
           <a:p>
-            <a:fld id="{7EB76E00-5A08-439C-95EF-3524E9C729DA}" type="slidenum">
+            <a:fld id="{5704788F-762F-4466-8534-F2D60E916612}" type="slidenum">
               <a:rPr lang="en-US" smtClean="0"/>
               <a:t>‹#›</a:t>
             </a:fld>
@@ -3621,7 +4018,7 @@
     </p:spTree>
     <p:extLst>
       <p:ext uri="{BB962C8B-B14F-4D97-AF65-F5344CB8AC3E}">
-        <p14:creationId xmlns:p14="http://schemas.microsoft.com/office/powerpoint/2010/main" val="2345126985"/>
+        <p14:creationId xmlns:p14="http://schemas.microsoft.com/office/powerpoint/2010/main" val="2749942145"/>
       </p:ext>
     </p:extLst>
   </p:cSld>
@@ -4232,7 +4629,811 @@
     </p:spTree>
     <p:extLst>
       <p:ext uri="{BB962C8B-B14F-4D97-AF65-F5344CB8AC3E}">
-        <p14:creationId xmlns:p14="http://schemas.microsoft.com/office/powerpoint/2010/main" val="2999668833"/>
+        <p14:creationId xmlns:p14="http://schemas.microsoft.com/office/powerpoint/2010/main" val="271748846"/>
+      </p:ext>
+    </p:extLst>
+  </p:cSld>
+  <p:clrMapOvr>
+    <a:masterClrMapping/>
+  </p:clrMapOvr>
+</p:sld>
+</file>
+
+<file path=ppt/slides/slide10.xml><?xml version="1.0" encoding="utf-8"?>
+<p:sld xmlns:a="http://schemas.openxmlformats.org/drawingml/2006/main" xmlns:r="http://schemas.openxmlformats.org/officeDocument/2006/relationships" xmlns:p="http://schemas.openxmlformats.org/presentationml/2006/main">
+  <p:cSld>
+    <p:bg>
+      <p:bgPr>
+        <a:solidFill>
+          <a:srgbClr val="0F272A"/>
+        </a:solidFill>
+        <a:effectLst/>
+      </p:bgPr>
+    </p:bg>
+    <p:spTree>
+      <p:nvGrpSpPr>
+        <p:cNvPr id="1" name=""/>
+        <p:cNvGrpSpPr/>
+        <p:nvPr/>
+      </p:nvGrpSpPr>
+      <p:grpSpPr>
+        <a:xfrm>
+          <a:off x="0" y="0"/>
+          <a:ext cx="0" cy="0"/>
+          <a:chOff x="0" y="0"/>
+          <a:chExt cx="0" cy="0"/>
+        </a:xfrm>
+      </p:grpSpPr>
+      <p:sp>
+        <p:nvSpPr>
+          <p:cNvPr id="2" name="TextBox 1"/>
+          <p:cNvSpPr txBox="1"/>
+          <p:nvPr/>
+        </p:nvSpPr>
+        <p:spPr>
+          <a:xfrm>
+            <a:off x="381000" y="152400"/>
+            <a:ext cx="10795000" cy="261610"/>
+          </a:xfrm>
+          <a:prstGeom prst="rect">
+            <a:avLst/>
+          </a:prstGeom>
+          <a:noFill/>
+        </p:spPr>
+        <p:txBody>
+          <a:bodyPr vert="horz" rtlCol="0">
+            <a:spAutoFit/>
+          </a:bodyPr>
+          <a:lstStyle/>
+          <a:p>
+            <a:r>
+              <a:rPr lang="en-US" sz="1100" smtClean="0">
+                <a:solidFill>
+                  <a:srgbClr val="5EEAD4"/>
+                </a:solidFill>
+                <a:latin typeface="Segoe UI" panose="020B0502040204020203" pitchFamily="34" charset="0"/>
+              </a:rPr>
+              <a:t>EVENTSPROJECT  /  MODULE TACHE</a:t>
+            </a:r>
+            <a:endParaRPr lang="en-US" sz="1100">
+              <a:solidFill>
+                <a:srgbClr val="5EEAD4"/>
+              </a:solidFill>
+              <a:latin typeface="Segoe UI" panose="020B0502040204020203" pitchFamily="34" charset="0"/>
+            </a:endParaRPr>
+          </a:p>
+        </p:txBody>
+      </p:sp>
+      <p:sp>
+        <p:nvSpPr>
+          <p:cNvPr id="3" name="TextBox 2"/>
+          <p:cNvSpPr txBox="1"/>
+          <p:nvPr/>
+        </p:nvSpPr>
+        <p:spPr>
+          <a:xfrm>
+            <a:off x="381000" y="533400"/>
+            <a:ext cx="11430000" cy="523220"/>
+          </a:xfrm>
+          <a:prstGeom prst="rect">
+            <a:avLst/>
+          </a:prstGeom>
+          <a:noFill/>
+        </p:spPr>
+        <p:txBody>
+          <a:bodyPr vert="horz" rtlCol="0">
+            <a:spAutoFit/>
+          </a:bodyPr>
+          <a:lstStyle/>
+          <a:p>
+            <a:r>
+              <a:rPr lang="en-US" sz="2800" smtClean="0">
+                <a:solidFill>
+                  <a:srgbClr val="FFFFFF"/>
+                </a:solidFill>
+                <a:latin typeface="Segoe UI" panose="020B0502040204020203" pitchFamily="34" charset="0"/>
+              </a:rPr>
+              <a:t>Une couverture m?tier mesur?e</a:t>
+            </a:r>
+            <a:endParaRPr lang="en-US" sz="2800">
+              <a:solidFill>
+                <a:srgbClr val="FFFFFF"/>
+              </a:solidFill>
+              <a:latin typeface="Segoe UI" panose="020B0502040204020203" pitchFamily="34" charset="0"/>
+            </a:endParaRPr>
+          </a:p>
+        </p:txBody>
+      </p:sp>
+      <p:sp>
+        <p:nvSpPr>
+          <p:cNvPr id="4" name="TextBox 3"/>
+          <p:cNvSpPr txBox="1"/>
+          <p:nvPr/>
+        </p:nvSpPr>
+        <p:spPr>
+          <a:xfrm>
+            <a:off x="381000" y="1244600"/>
+            <a:ext cx="11430000" cy="338554"/>
+          </a:xfrm>
+          <a:prstGeom prst="rect">
+            <a:avLst/>
+          </a:prstGeom>
+          <a:noFill/>
+        </p:spPr>
+        <p:txBody>
+          <a:bodyPr vert="horz" rtlCol="0">
+            <a:spAutoFit/>
+          </a:bodyPr>
+          <a:lstStyle/>
+          <a:p>
+            <a:r>
+              <a:rPr lang="fr-FR" sz="1600" smtClean="0">
+                <a:solidFill>
+                  <a:srgbClr val="E1E1E1"/>
+                </a:solidFill>
+                <a:latin typeface="Segoe UI" panose="020B0502040204020203" pitchFamily="34" charset="0"/>
+              </a:rPr>
+              <a:t>TacheService : 24 lignes et 4 branches couvertes ; ce r?sultat concerne ce service.</a:t>
+            </a:r>
+            <a:endParaRPr lang="en-US" sz="1600">
+              <a:solidFill>
+                <a:srgbClr val="E1E1E1"/>
+              </a:solidFill>
+              <a:latin typeface="Segoe UI" panose="020B0502040204020203" pitchFamily="34" charset="0"/>
+            </a:endParaRPr>
+          </a:p>
+        </p:txBody>
+      </p:sp>
+      <p:pic>
+        <p:nvPicPr>
+          <p:cNvPr id="5" name="Picture 4"/>
+          <p:cNvPicPr>
+            <a:picLocks noChangeAspect="1"/>
+          </p:cNvPicPr>
+          <p:nvPr/>
+        </p:nvPicPr>
+        <p:blipFill>
+          <a:blip r:embed="rId3">
+            <a:extLst>
+              <a:ext uri="{28A0092B-C50C-407E-A947-70E740481C1C}">
+                <a14:useLocalDpi xmlns:a14="http://schemas.microsoft.com/office/drawing/2010/main" val="0"/>
+              </a:ext>
+            </a:extLst>
+          </a:blip>
+          <a:stretch>
+            <a:fillRect/>
+          </a:stretch>
+        </p:blipFill>
+        <p:spPr>
+          <a:xfrm>
+            <a:off x="1952465" y="1981200"/>
+            <a:ext cx="8287071" cy="4318000"/>
+          </a:xfrm>
+          <a:prstGeom prst="rect">
+            <a:avLst/>
+          </a:prstGeom>
+        </p:spPr>
+      </p:pic>
+      <p:sp>
+        <p:nvSpPr>
+          <p:cNvPr id="6" name="TextBox 5"/>
+          <p:cNvSpPr txBox="1"/>
+          <p:nvPr/>
+        </p:nvSpPr>
+        <p:spPr>
+          <a:xfrm>
+            <a:off x="381000" y="6400800"/>
+            <a:ext cx="10795000" cy="230832"/>
+          </a:xfrm>
+          <a:prstGeom prst="rect">
+            <a:avLst/>
+          </a:prstGeom>
+          <a:noFill/>
+        </p:spPr>
+        <p:txBody>
+          <a:bodyPr vert="horz" rtlCol="0">
+            <a:spAutoFit/>
+          </a:bodyPr>
+          <a:lstStyle/>
+          <a:p>
+            <a:r>
+              <a:rPr lang="en-US" sz="900" smtClean="0">
+                <a:solidFill>
+                  <a:srgbClr val="5EEAD4"/>
+                </a:solidFill>
+                <a:latin typeface="Segoe UI" panose="020B0502040204020203" pitchFamily="34" charset="0"/>
+              </a:rPr>
+              <a:t>Preuve : 04-unit-tests/coverage-service.png</a:t>
+            </a:r>
+            <a:endParaRPr lang="en-US" sz="900">
+              <a:solidFill>
+                <a:srgbClr val="5EEAD4"/>
+              </a:solidFill>
+              <a:latin typeface="Segoe UI" panose="020B0502040204020203" pitchFamily="34" charset="0"/>
+            </a:endParaRPr>
+          </a:p>
+        </p:txBody>
+      </p:sp>
+      <p:sp>
+        <p:nvSpPr>
+          <p:cNvPr id="7" name="TextBox 6"/>
+          <p:cNvSpPr txBox="1"/>
+          <p:nvPr/>
+        </p:nvSpPr>
+        <p:spPr>
+          <a:xfrm>
+            <a:off x="11582400" y="6438900"/>
+            <a:ext cx="381000" cy="246221"/>
+          </a:xfrm>
+          <a:prstGeom prst="rect">
+            <a:avLst/>
+          </a:prstGeom>
+          <a:noFill/>
+        </p:spPr>
+        <p:txBody>
+          <a:bodyPr vert="horz" rtlCol="0">
+            <a:spAutoFit/>
+          </a:bodyPr>
+          <a:lstStyle/>
+          <a:p>
+            <a:r>
+              <a:rPr lang="en-US" sz="1000" smtClean="0">
+                <a:solidFill>
+                  <a:srgbClr val="E1E1E1"/>
+                </a:solidFill>
+                <a:latin typeface="Segoe UI" panose="020B0502040204020203" pitchFamily="34" charset="0"/>
+              </a:rPr>
+              <a:t>10</a:t>
+            </a:r>
+            <a:endParaRPr lang="en-US" sz="1000">
+              <a:solidFill>
+                <a:srgbClr val="E1E1E1"/>
+              </a:solidFill>
+              <a:latin typeface="Segoe UI" panose="020B0502040204020203" pitchFamily="34" charset="0"/>
+            </a:endParaRPr>
+          </a:p>
+        </p:txBody>
+      </p:sp>
+    </p:spTree>
+    <p:extLst>
+      <p:ext uri="{BB962C8B-B14F-4D97-AF65-F5344CB8AC3E}">
+        <p14:creationId xmlns:p14="http://schemas.microsoft.com/office/powerpoint/2010/main" val="3100078931"/>
+      </p:ext>
+    </p:extLst>
+  </p:cSld>
+  <p:clrMapOvr>
+    <a:masterClrMapping/>
+  </p:clrMapOvr>
+</p:sld>
+</file>
+
+<file path=ppt/slides/slide11.xml><?xml version="1.0" encoding="utf-8"?>
+<p:sld xmlns:a="http://schemas.openxmlformats.org/drawingml/2006/main" xmlns:r="http://schemas.openxmlformats.org/officeDocument/2006/relationships" xmlns:p="http://schemas.openxmlformats.org/presentationml/2006/main">
+  <p:cSld>
+    <p:bg>
+      <p:bgPr>
+        <a:solidFill>
+          <a:srgbClr val="0F272A"/>
+        </a:solidFill>
+        <a:effectLst/>
+      </p:bgPr>
+    </p:bg>
+    <p:spTree>
+      <p:nvGrpSpPr>
+        <p:cNvPr id="1" name=""/>
+        <p:cNvGrpSpPr/>
+        <p:nvPr/>
+      </p:nvGrpSpPr>
+      <p:grpSpPr>
+        <a:xfrm>
+          <a:off x="0" y="0"/>
+          <a:ext cx="0" cy="0"/>
+          <a:chOff x="0" y="0"/>
+          <a:chExt cx="0" cy="0"/>
+        </a:xfrm>
+      </p:grpSpPr>
+      <p:sp>
+        <p:nvSpPr>
+          <p:cNvPr id="2" name="TextBox 1"/>
+          <p:cNvSpPr txBox="1"/>
+          <p:nvPr/>
+        </p:nvSpPr>
+        <p:spPr>
+          <a:xfrm>
+            <a:off x="381000" y="152400"/>
+            <a:ext cx="10795000" cy="261610"/>
+          </a:xfrm>
+          <a:prstGeom prst="rect">
+            <a:avLst/>
+          </a:prstGeom>
+          <a:noFill/>
+        </p:spPr>
+        <p:txBody>
+          <a:bodyPr vert="horz" rtlCol="0">
+            <a:spAutoFit/>
+          </a:bodyPr>
+          <a:lstStyle/>
+          <a:p>
+            <a:r>
+              <a:rPr lang="en-US" sz="1100" smtClean="0">
+                <a:solidFill>
+                  <a:srgbClr val="5EEAD4"/>
+                </a:solidFill>
+                <a:latin typeface="Segoe UI" panose="020B0502040204020203" pitchFamily="34" charset="0"/>
+              </a:rPr>
+              <a:t>EVENTSPROJECT  /  MODULE TACHE</a:t>
+            </a:r>
+            <a:endParaRPr lang="en-US" sz="1100">
+              <a:solidFill>
+                <a:srgbClr val="5EEAD4"/>
+              </a:solidFill>
+              <a:latin typeface="Segoe UI" panose="020B0502040204020203" pitchFamily="34" charset="0"/>
+            </a:endParaRPr>
+          </a:p>
+        </p:txBody>
+      </p:sp>
+      <p:sp>
+        <p:nvSpPr>
+          <p:cNvPr id="3" name="TextBox 2"/>
+          <p:cNvSpPr txBox="1"/>
+          <p:nvPr/>
+        </p:nvSpPr>
+        <p:spPr>
+          <a:xfrm>
+            <a:off x="381000" y="533400"/>
+            <a:ext cx="11430000" cy="523220"/>
+          </a:xfrm>
+          <a:prstGeom prst="rect">
+            <a:avLst/>
+          </a:prstGeom>
+          <a:noFill/>
+        </p:spPr>
+        <p:txBody>
+          <a:bodyPr vert="horz" rtlCol="0">
+            <a:spAutoFit/>
+          </a:bodyPr>
+          <a:lstStyle/>
+          <a:p>
+            <a:r>
+              <a:rPr lang="fr-FR" sz="2800" smtClean="0">
+                <a:solidFill>
+                  <a:srgbClr val="FFFFFF"/>
+                </a:solidFill>
+                <a:latin typeface="Segoe UI" panose="020B0502040204020203" pitchFamily="34" charset="0"/>
+              </a:rPr>
+              <a:t>Journaliser les op?rations et les erreurs</a:t>
+            </a:r>
+            <a:endParaRPr lang="en-US" sz="2800">
+              <a:solidFill>
+                <a:srgbClr val="FFFFFF"/>
+              </a:solidFill>
+              <a:latin typeface="Segoe UI" panose="020B0502040204020203" pitchFamily="34" charset="0"/>
+            </a:endParaRPr>
+          </a:p>
+        </p:txBody>
+      </p:sp>
+      <p:sp>
+        <p:nvSpPr>
+          <p:cNvPr id="4" name="TextBox 3"/>
+          <p:cNvSpPr txBox="1"/>
+          <p:nvPr/>
+        </p:nvSpPr>
+        <p:spPr>
+          <a:xfrm>
+            <a:off x="381000" y="1244600"/>
+            <a:ext cx="11430000" cy="338554"/>
+          </a:xfrm>
+          <a:prstGeom prst="rect">
+            <a:avLst/>
+          </a:prstGeom>
+          <a:noFill/>
+        </p:spPr>
+        <p:txBody>
+          <a:bodyPr vert="horz" rtlCol="0">
+            <a:spAutoFit/>
+          </a:bodyPr>
+          <a:lstStyle/>
+          <a:p>
+            <a:r>
+              <a:rPr lang="fr-FR" sz="1600" smtClean="0">
+                <a:solidFill>
+                  <a:srgbClr val="E1E1E1"/>
+                </a:solidFill>
+                <a:latin typeface="Segoe UI" panose="020B0502040204020203" pitchFamily="34" charset="0"/>
+              </a:rPr>
+              <a:t>DEBUG, INFO, WARN sur API ; ERROR d?montr? par une panne simul?e dans un test.</a:t>
+            </a:r>
+            <a:endParaRPr lang="en-US" sz="1600">
+              <a:solidFill>
+                <a:srgbClr val="E1E1E1"/>
+              </a:solidFill>
+              <a:latin typeface="Segoe UI" panose="020B0502040204020203" pitchFamily="34" charset="0"/>
+            </a:endParaRPr>
+          </a:p>
+        </p:txBody>
+      </p:sp>
+      <p:pic>
+        <p:nvPicPr>
+          <p:cNvPr id="5" name="Picture 4"/>
+          <p:cNvPicPr>
+            <a:picLocks noChangeAspect="1"/>
+          </p:cNvPicPr>
+          <p:nvPr/>
+        </p:nvPicPr>
+        <p:blipFill>
+          <a:blip r:embed="rId3">
+            <a:extLst>
+              <a:ext uri="{28A0092B-C50C-407E-A947-70E740481C1C}">
+                <a14:useLocalDpi xmlns:a14="http://schemas.microsoft.com/office/drawing/2010/main" val="0"/>
+              </a:ext>
+            </a:extLst>
+          </a:blip>
+          <a:stretch>
+            <a:fillRect/>
+          </a:stretch>
+        </p:blipFill>
+        <p:spPr>
+          <a:xfrm>
+            <a:off x="1952465" y="1981200"/>
+            <a:ext cx="8287071" cy="4318000"/>
+          </a:xfrm>
+          <a:prstGeom prst="rect">
+            <a:avLst/>
+          </a:prstGeom>
+        </p:spPr>
+      </p:pic>
+      <p:sp>
+        <p:nvSpPr>
+          <p:cNvPr id="6" name="TextBox 5"/>
+          <p:cNvSpPr txBox="1"/>
+          <p:nvPr/>
+        </p:nvSpPr>
+        <p:spPr>
+          <a:xfrm>
+            <a:off x="381000" y="6400800"/>
+            <a:ext cx="10795000" cy="230832"/>
+          </a:xfrm>
+          <a:prstGeom prst="rect">
+            <a:avLst/>
+          </a:prstGeom>
+          <a:noFill/>
+        </p:spPr>
+        <p:txBody>
+          <a:bodyPr vert="horz" rtlCol="0">
+            <a:spAutoFit/>
+          </a:bodyPr>
+          <a:lstStyle/>
+          <a:p>
+            <a:r>
+              <a:rPr lang="en-US" sz="900" smtClean="0">
+                <a:solidFill>
+                  <a:srgbClr val="5EEAD4"/>
+                </a:solidFill>
+                <a:latin typeface="Segoe UI" panose="020B0502040204020203" pitchFamily="34" charset="0"/>
+              </a:rPr>
+              <a:t>Preuve : 03-logging/tache-levels.png</a:t>
+            </a:r>
+            <a:endParaRPr lang="en-US" sz="900">
+              <a:solidFill>
+                <a:srgbClr val="5EEAD4"/>
+              </a:solidFill>
+              <a:latin typeface="Segoe UI" panose="020B0502040204020203" pitchFamily="34" charset="0"/>
+            </a:endParaRPr>
+          </a:p>
+        </p:txBody>
+      </p:sp>
+      <p:sp>
+        <p:nvSpPr>
+          <p:cNvPr id="7" name="TextBox 6"/>
+          <p:cNvSpPr txBox="1"/>
+          <p:nvPr/>
+        </p:nvSpPr>
+        <p:spPr>
+          <a:xfrm>
+            <a:off x="11582400" y="6438900"/>
+            <a:ext cx="381000" cy="246221"/>
+          </a:xfrm>
+          <a:prstGeom prst="rect">
+            <a:avLst/>
+          </a:prstGeom>
+          <a:noFill/>
+        </p:spPr>
+        <p:txBody>
+          <a:bodyPr vert="horz" rtlCol="0">
+            <a:spAutoFit/>
+          </a:bodyPr>
+          <a:lstStyle/>
+          <a:p>
+            <a:r>
+              <a:rPr lang="en-US" sz="1000" smtClean="0">
+                <a:solidFill>
+                  <a:srgbClr val="E1E1E1"/>
+                </a:solidFill>
+                <a:latin typeface="Segoe UI" panose="020B0502040204020203" pitchFamily="34" charset="0"/>
+              </a:rPr>
+              <a:t>11</a:t>
+            </a:r>
+            <a:endParaRPr lang="en-US" sz="1000">
+              <a:solidFill>
+                <a:srgbClr val="E1E1E1"/>
+              </a:solidFill>
+              <a:latin typeface="Segoe UI" panose="020B0502040204020203" pitchFamily="34" charset="0"/>
+            </a:endParaRPr>
+          </a:p>
+        </p:txBody>
+      </p:sp>
+    </p:spTree>
+    <p:extLst>
+      <p:ext uri="{BB962C8B-B14F-4D97-AF65-F5344CB8AC3E}">
+        <p14:creationId xmlns:p14="http://schemas.microsoft.com/office/powerpoint/2010/main" val="3230944381"/>
+      </p:ext>
+    </p:extLst>
+  </p:cSld>
+  <p:clrMapOvr>
+    <a:masterClrMapping/>
+  </p:clrMapOvr>
+</p:sld>
+</file>
+
+<file path=ppt/slides/slide12.xml><?xml version="1.0" encoding="utf-8"?>
+<p:sld xmlns:a="http://schemas.openxmlformats.org/drawingml/2006/main" xmlns:r="http://schemas.openxmlformats.org/officeDocument/2006/relationships" xmlns:p="http://schemas.openxmlformats.org/presentationml/2006/main">
+  <p:cSld>
+    <p:bg>
+      <p:bgPr>
+        <a:solidFill>
+          <a:srgbClr val="0F272A"/>
+        </a:solidFill>
+        <a:effectLst/>
+      </p:bgPr>
+    </p:bg>
+    <p:spTree>
+      <p:nvGrpSpPr>
+        <p:cNvPr id="1" name=""/>
+        <p:cNvGrpSpPr/>
+        <p:nvPr/>
+      </p:nvGrpSpPr>
+      <p:grpSpPr>
+        <a:xfrm>
+          <a:off x="0" y="0"/>
+          <a:ext cx="0" cy="0"/>
+          <a:chOff x="0" y="0"/>
+          <a:chExt cx="0" cy="0"/>
+        </a:xfrm>
+      </p:grpSpPr>
+      <p:sp>
+        <p:nvSpPr>
+          <p:cNvPr id="2" name="TextBox 1"/>
+          <p:cNvSpPr txBox="1"/>
+          <p:nvPr/>
+        </p:nvSpPr>
+        <p:spPr>
+          <a:xfrm>
+            <a:off x="381000" y="152400"/>
+            <a:ext cx="10795000" cy="261610"/>
+          </a:xfrm>
+          <a:prstGeom prst="rect">
+            <a:avLst/>
+          </a:prstGeom>
+          <a:noFill/>
+        </p:spPr>
+        <p:txBody>
+          <a:bodyPr vert="horz" rtlCol="0">
+            <a:spAutoFit/>
+          </a:bodyPr>
+          <a:lstStyle/>
+          <a:p>
+            <a:r>
+              <a:rPr lang="en-US" sz="1100" smtClean="0">
+                <a:solidFill>
+                  <a:srgbClr val="5EEAD4"/>
+                </a:solidFill>
+                <a:latin typeface="Segoe UI" panose="020B0502040204020203" pitchFamily="34" charset="0"/>
+              </a:rPr>
+              <a:t>EVENTSPROJECT  /  MODULE TACHE</a:t>
+            </a:r>
+            <a:endParaRPr lang="en-US" sz="1100">
+              <a:solidFill>
+                <a:srgbClr val="5EEAD4"/>
+              </a:solidFill>
+              <a:latin typeface="Segoe UI" panose="020B0502040204020203" pitchFamily="34" charset="0"/>
+            </a:endParaRPr>
+          </a:p>
+        </p:txBody>
+      </p:sp>
+      <p:sp>
+        <p:nvSpPr>
+          <p:cNvPr id="3" name="TextBox 2"/>
+          <p:cNvSpPr txBox="1"/>
+          <p:nvPr/>
+        </p:nvSpPr>
+        <p:spPr>
+          <a:xfrm>
+            <a:off x="381000" y="533400"/>
+            <a:ext cx="11430000" cy="523220"/>
+          </a:xfrm>
+          <a:prstGeom prst="rect">
+            <a:avLst/>
+          </a:prstGeom>
+          <a:noFill/>
+        </p:spPr>
+        <p:txBody>
+          <a:bodyPr vert="horz" rtlCol="0">
+            <a:spAutoFit/>
+          </a:bodyPr>
+          <a:lstStyle/>
+          <a:p>
+            <a:r>
+              <a:rPr lang="fr-FR" sz="2800" smtClean="0">
+                <a:solidFill>
+                  <a:srgbClr val="FFFFFF"/>
+                </a:solidFill>
+                <a:latin typeface="Segoe UI" panose="020B0502040204020203" pitchFamily="34" charset="0"/>
+              </a:rPr>
+              <a:t>Application et MySQL en conteneurs</a:t>
+            </a:r>
+            <a:endParaRPr lang="en-US" sz="2800">
+              <a:solidFill>
+                <a:srgbClr val="FFFFFF"/>
+              </a:solidFill>
+              <a:latin typeface="Segoe UI" panose="020B0502040204020203" pitchFamily="34" charset="0"/>
+            </a:endParaRPr>
+          </a:p>
+        </p:txBody>
+      </p:sp>
+      <p:sp>
+        <p:nvSpPr>
+          <p:cNvPr id="4" name="TextBox 3"/>
+          <p:cNvSpPr txBox="1"/>
+          <p:nvPr/>
+        </p:nvSpPr>
+        <p:spPr>
+          <a:xfrm>
+            <a:off x="381000" y="1244600"/>
+            <a:ext cx="11430000" cy="338554"/>
+          </a:xfrm>
+          <a:prstGeom prst="rect">
+            <a:avLst/>
+          </a:prstGeom>
+          <a:noFill/>
+        </p:spPr>
+        <p:txBody>
+          <a:bodyPr vert="horz" rtlCol="0">
+            <a:spAutoFit/>
+          </a:bodyPr>
+          <a:lstStyle/>
+          <a:p>
+            <a:r>
+              <a:rPr lang="fr-FR" sz="1600" smtClean="0">
+                <a:solidFill>
+                  <a:srgbClr val="E1E1E1"/>
+                </a:solidFill>
+                <a:latin typeface="Segoe UI" panose="020B0502040204020203" pitchFamily="34" charset="0"/>
+              </a:rPr>
+              <a:t>Cycle HTTP v?rifi? dans Docker ; readiness UP et utilisateur applicatif non privil?gi?.</a:t>
+            </a:r>
+            <a:endParaRPr lang="en-US" sz="1600">
+              <a:solidFill>
+                <a:srgbClr val="E1E1E1"/>
+              </a:solidFill>
+              <a:latin typeface="Segoe UI" panose="020B0502040204020203" pitchFamily="34" charset="0"/>
+            </a:endParaRPr>
+          </a:p>
+        </p:txBody>
+      </p:sp>
+      <p:pic>
+        <p:nvPicPr>
+          <p:cNvPr id="5" name="Picture 4"/>
+          <p:cNvPicPr>
+            <a:picLocks noChangeAspect="1"/>
+          </p:cNvPicPr>
+          <p:nvPr/>
+        </p:nvPicPr>
+        <p:blipFill>
+          <a:blip r:embed="rId3">
+            <a:extLst>
+              <a:ext uri="{28A0092B-C50C-407E-A947-70E740481C1C}">
+                <a14:useLocalDpi xmlns:a14="http://schemas.microsoft.com/office/drawing/2010/main" val="0"/>
+              </a:ext>
+            </a:extLst>
+          </a:blip>
+          <a:stretch>
+            <a:fillRect/>
+          </a:stretch>
+        </p:blipFill>
+        <p:spPr>
+          <a:xfrm>
+            <a:off x="1952465" y="1981200"/>
+            <a:ext cx="8287071" cy="4318000"/>
+          </a:xfrm>
+          <a:prstGeom prst="rect">
+            <a:avLst/>
+          </a:prstGeom>
+        </p:spPr>
+      </p:pic>
+      <p:sp>
+        <p:nvSpPr>
+          <p:cNvPr id="6" name="TextBox 5"/>
+          <p:cNvSpPr txBox="1"/>
+          <p:nvPr/>
+        </p:nvSpPr>
+        <p:spPr>
+          <a:xfrm>
+            <a:off x="381000" y="6400800"/>
+            <a:ext cx="10795000" cy="230832"/>
+          </a:xfrm>
+          <a:prstGeom prst="rect">
+            <a:avLst/>
+          </a:prstGeom>
+          <a:noFill/>
+        </p:spPr>
+        <p:txBody>
+          <a:bodyPr vert="horz" rtlCol="0">
+            <a:spAutoFit/>
+          </a:bodyPr>
+          <a:lstStyle/>
+          <a:p>
+            <a:r>
+              <a:rPr lang="en-US" sz="900" smtClean="0">
+                <a:solidFill>
+                  <a:srgbClr val="5EEAD4"/>
+                </a:solidFill>
+                <a:latin typeface="Segoe UI" panose="020B0502040204020203" pitchFamily="34" charset="0"/>
+              </a:rPr>
+              <a:t>Preuve : 09-docker/docker-api-success.png</a:t>
+            </a:r>
+            <a:endParaRPr lang="en-US" sz="900">
+              <a:solidFill>
+                <a:srgbClr val="5EEAD4"/>
+              </a:solidFill>
+              <a:latin typeface="Segoe UI" panose="020B0502040204020203" pitchFamily="34" charset="0"/>
+            </a:endParaRPr>
+          </a:p>
+        </p:txBody>
+      </p:sp>
+      <p:sp>
+        <p:nvSpPr>
+          <p:cNvPr id="7" name="TextBox 6"/>
+          <p:cNvSpPr txBox="1"/>
+          <p:nvPr/>
+        </p:nvSpPr>
+        <p:spPr>
+          <a:xfrm>
+            <a:off x="11582400" y="6438900"/>
+            <a:ext cx="381000" cy="246221"/>
+          </a:xfrm>
+          <a:prstGeom prst="rect">
+            <a:avLst/>
+          </a:prstGeom>
+          <a:noFill/>
+        </p:spPr>
+        <p:txBody>
+          <a:bodyPr vert="horz" rtlCol="0">
+            <a:spAutoFit/>
+          </a:bodyPr>
+          <a:lstStyle/>
+          <a:p>
+            <a:r>
+              <a:rPr lang="en-US" sz="1000" smtClean="0">
+                <a:solidFill>
+                  <a:srgbClr val="E1E1E1"/>
+                </a:solidFill>
+                <a:latin typeface="Segoe UI" panose="020B0502040204020203" pitchFamily="34" charset="0"/>
+              </a:rPr>
+              <a:t>12</a:t>
+            </a:r>
+            <a:endParaRPr lang="en-US" sz="1000">
+              <a:solidFill>
+                <a:srgbClr val="E1E1E1"/>
+              </a:solidFill>
+              <a:latin typeface="Segoe UI" panose="020B0502040204020203" pitchFamily="34" charset="0"/>
+            </a:endParaRPr>
+          </a:p>
+        </p:txBody>
+      </p:sp>
+    </p:spTree>
+    <p:extLst>
+      <p:ext uri="{BB962C8B-B14F-4D97-AF65-F5344CB8AC3E}">
+        <p14:creationId xmlns:p14="http://schemas.microsoft.com/office/powerpoint/2010/main" val="839782362"/>
       </p:ext>
     </p:extLst>
   </p:cSld>
@@ -4500,7 +5701,7 @@
     </p:spTree>
     <p:extLst>
       <p:ext uri="{BB962C8B-B14F-4D97-AF65-F5344CB8AC3E}">
-        <p14:creationId xmlns:p14="http://schemas.microsoft.com/office/powerpoint/2010/main" val="555010622"/>
+        <p14:creationId xmlns:p14="http://schemas.microsoft.com/office/powerpoint/2010/main" val="1090501981"/>
       </p:ext>
     </p:extLst>
   </p:cSld>
@@ -4768,7 +5969,7 @@
     </p:spTree>
     <p:extLst>
       <p:ext uri="{BB962C8B-B14F-4D97-AF65-F5344CB8AC3E}">
-        <p14:creationId xmlns:p14="http://schemas.microsoft.com/office/powerpoint/2010/main" val="3848502691"/>
+        <p14:creationId xmlns:p14="http://schemas.microsoft.com/office/powerpoint/2010/main" val="1279971180"/>
       </p:ext>
     </p:extLst>
   </p:cSld>
@@ -5036,7 +6237,7 @@
     </p:spTree>
     <p:extLst>
       <p:ext uri="{BB962C8B-B14F-4D97-AF65-F5344CB8AC3E}">
-        <p14:creationId xmlns:p14="http://schemas.microsoft.com/office/powerpoint/2010/main" val="964661063"/>
+        <p14:creationId xmlns:p14="http://schemas.microsoft.com/office/powerpoint/2010/main" val="3535514103"/>
       </p:ext>
     </p:extLst>
   </p:cSld>
@@ -5304,7 +6505,7 @@
     </p:spTree>
     <p:extLst>
       <p:ext uri="{BB962C8B-B14F-4D97-AF65-F5344CB8AC3E}">
-        <p14:creationId xmlns:p14="http://schemas.microsoft.com/office/powerpoint/2010/main" val="3452200266"/>
+        <p14:creationId xmlns:p14="http://schemas.microsoft.com/office/powerpoint/2010/main" val="1098613307"/>
       </p:ext>
     </p:extLst>
   </p:cSld>
@@ -5572,7 +6773,7 @@
     </p:spTree>
     <p:extLst>
       <p:ext uri="{BB962C8B-B14F-4D97-AF65-F5344CB8AC3E}">
-        <p14:creationId xmlns:p14="http://schemas.microsoft.com/office/powerpoint/2010/main" val="1380015705"/>
+        <p14:creationId xmlns:p14="http://schemas.microsoft.com/office/powerpoint/2010/main" val="289912963"/>
       </p:ext>
     </p:extLst>
   </p:cSld>
@@ -5893,7 +7094,543 @@
     </p:spTree>
     <p:extLst>
       <p:ext uri="{BB962C8B-B14F-4D97-AF65-F5344CB8AC3E}">
-        <p14:creationId xmlns:p14="http://schemas.microsoft.com/office/powerpoint/2010/main" val="3660078778"/>
+        <p14:creationId xmlns:p14="http://schemas.microsoft.com/office/powerpoint/2010/main" val="3370315337"/>
+      </p:ext>
+    </p:extLst>
+  </p:cSld>
+  <p:clrMapOvr>
+    <a:masterClrMapping/>
+  </p:clrMapOvr>
+</p:sld>
+</file>
+
+<file path=ppt/slides/slide8.xml><?xml version="1.0" encoding="utf-8"?>
+<p:sld xmlns:a="http://schemas.openxmlformats.org/drawingml/2006/main" xmlns:r="http://schemas.openxmlformats.org/officeDocument/2006/relationships" xmlns:p="http://schemas.openxmlformats.org/presentationml/2006/main">
+  <p:cSld>
+    <p:bg>
+      <p:bgPr>
+        <a:solidFill>
+          <a:srgbClr val="0F272A"/>
+        </a:solidFill>
+        <a:effectLst/>
+      </p:bgPr>
+    </p:bg>
+    <p:spTree>
+      <p:nvGrpSpPr>
+        <p:cNvPr id="1" name=""/>
+        <p:cNvGrpSpPr/>
+        <p:nvPr/>
+      </p:nvGrpSpPr>
+      <p:grpSpPr>
+        <a:xfrm>
+          <a:off x="0" y="0"/>
+          <a:ext cx="0" cy="0"/>
+          <a:chOff x="0" y="0"/>
+          <a:chExt cx="0" cy="0"/>
+        </a:xfrm>
+      </p:grpSpPr>
+      <p:sp>
+        <p:nvSpPr>
+          <p:cNvPr id="2" name="TextBox 1"/>
+          <p:cNvSpPr txBox="1"/>
+          <p:nvPr/>
+        </p:nvSpPr>
+        <p:spPr>
+          <a:xfrm>
+            <a:off x="381000" y="152400"/>
+            <a:ext cx="10795000" cy="261610"/>
+          </a:xfrm>
+          <a:prstGeom prst="rect">
+            <a:avLst/>
+          </a:prstGeom>
+          <a:noFill/>
+        </p:spPr>
+        <p:txBody>
+          <a:bodyPr vert="horz" rtlCol="0">
+            <a:spAutoFit/>
+          </a:bodyPr>
+          <a:lstStyle/>
+          <a:p>
+            <a:r>
+              <a:rPr lang="en-US" sz="1100" smtClean="0">
+                <a:solidFill>
+                  <a:srgbClr val="5EEAD4"/>
+                </a:solidFill>
+                <a:latin typeface="Segoe UI" panose="020B0502040204020203" pitchFamily="34" charset="0"/>
+              </a:rPr>
+              <a:t>EVENTSPROJECT  /  MODULE TACHE</a:t>
+            </a:r>
+            <a:endParaRPr lang="en-US" sz="1100">
+              <a:solidFill>
+                <a:srgbClr val="5EEAD4"/>
+              </a:solidFill>
+              <a:latin typeface="Segoe UI" panose="020B0502040204020203" pitchFamily="34" charset="0"/>
+            </a:endParaRPr>
+          </a:p>
+        </p:txBody>
+      </p:sp>
+      <p:sp>
+        <p:nvSpPr>
+          <p:cNvPr id="3" name="TextBox 2"/>
+          <p:cNvSpPr txBox="1"/>
+          <p:nvPr/>
+        </p:nvSpPr>
+        <p:spPr>
+          <a:xfrm>
+            <a:off x="381000" y="533400"/>
+            <a:ext cx="11430000" cy="523220"/>
+          </a:xfrm>
+          <a:prstGeom prst="rect">
+            <a:avLst/>
+          </a:prstGeom>
+          <a:noFill/>
+        </p:spPr>
+        <p:txBody>
+          <a:bodyPr vert="horz" rtlCol="0">
+            <a:spAutoFit/>
+          </a:bodyPr>
+          <a:lstStyle/>
+          <a:p>
+            <a:r>
+              <a:rPr lang="en-US" sz="2800" smtClean="0">
+                <a:solidFill>
+                  <a:srgbClr val="FFFFFF"/>
+                </a:solidFill>
+                <a:latin typeface="Segoe UI" panose="020B0502040204020203" pitchFamily="34" charset="0"/>
+              </a:rPr>
+              <a:t>MySQL : correction v?rifi?e</a:t>
+            </a:r>
+            <a:endParaRPr lang="en-US" sz="2800">
+              <a:solidFill>
+                <a:srgbClr val="FFFFFF"/>
+              </a:solidFill>
+              <a:latin typeface="Segoe UI" panose="020B0502040204020203" pitchFamily="34" charset="0"/>
+            </a:endParaRPr>
+          </a:p>
+        </p:txBody>
+      </p:sp>
+      <p:sp>
+        <p:nvSpPr>
+          <p:cNvPr id="4" name="TextBox 3"/>
+          <p:cNvSpPr txBox="1"/>
+          <p:nvPr/>
+        </p:nvSpPr>
+        <p:spPr>
+          <a:xfrm>
+            <a:off x="381000" y="1244600"/>
+            <a:ext cx="11430000" cy="338554"/>
+          </a:xfrm>
+          <a:prstGeom prst="rect">
+            <a:avLst/>
+          </a:prstGeom>
+          <a:noFill/>
+        </p:spPr>
+        <p:txBody>
+          <a:bodyPr vert="horz" rtlCol="0">
+            <a:spAutoFit/>
+          </a:bodyPr>
+          <a:lstStyle/>
+          <a:p>
+            <a:r>
+              <a:rPr lang="fr-FR" sz="1600" smtClean="0">
+                <a:solidFill>
+                  <a:srgbClr val="E1E1E1"/>
+                </a:solidFill>
+                <a:latin typeface="Segoe UI" panose="020B0502040204020203" pitchFamily="34" charset="0"/>
+              </a:rPr>
+              <a:t>Base d?di?e sur 3307 : cr?ation, affectation, lecture et retrait du r?le r?ussis.</a:t>
+            </a:r>
+            <a:endParaRPr lang="en-US" sz="1600">
+              <a:solidFill>
+                <a:srgbClr val="E1E1E1"/>
+              </a:solidFill>
+              <a:latin typeface="Segoe UI" panose="020B0502040204020203" pitchFamily="34" charset="0"/>
+            </a:endParaRPr>
+          </a:p>
+        </p:txBody>
+      </p:sp>
+      <p:pic>
+        <p:nvPicPr>
+          <p:cNvPr id="5" name="Picture 4"/>
+          <p:cNvPicPr>
+            <a:picLocks noChangeAspect="1"/>
+          </p:cNvPicPr>
+          <p:nvPr/>
+        </p:nvPicPr>
+        <p:blipFill>
+          <a:blip r:embed="rId3">
+            <a:extLst>
+              <a:ext uri="{28A0092B-C50C-407E-A947-70E740481C1C}">
+                <a14:useLocalDpi xmlns:a14="http://schemas.microsoft.com/office/drawing/2010/main" val="0"/>
+              </a:ext>
+            </a:extLst>
+          </a:blip>
+          <a:stretch>
+            <a:fillRect/>
+          </a:stretch>
+        </p:blipFill>
+        <p:spPr>
+          <a:xfrm>
+            <a:off x="1952465" y="1981200"/>
+            <a:ext cx="8287071" cy="4318000"/>
+          </a:xfrm>
+          <a:prstGeom prst="rect">
+            <a:avLst/>
+          </a:prstGeom>
+        </p:spPr>
+      </p:pic>
+      <p:sp>
+        <p:nvSpPr>
+          <p:cNvPr id="6" name="TextBox 5"/>
+          <p:cNvSpPr txBox="1"/>
+          <p:nvPr/>
+        </p:nvSpPr>
+        <p:spPr>
+          <a:xfrm>
+            <a:off x="381000" y="6400800"/>
+            <a:ext cx="10795000" cy="230832"/>
+          </a:xfrm>
+          <a:prstGeom prst="rect">
+            <a:avLst/>
+          </a:prstGeom>
+          <a:noFill/>
+        </p:spPr>
+        <p:txBody>
+          <a:bodyPr vert="horz" rtlCol="0">
+            <a:spAutoFit/>
+          </a:bodyPr>
+          <a:lstStyle/>
+          <a:p>
+            <a:r>
+              <a:rPr lang="en-US" sz="900" smtClean="0">
+                <a:solidFill>
+                  <a:srgbClr val="5EEAD4"/>
+                </a:solidFill>
+                <a:latin typeface="Segoe UI" panose="020B0502040204020203" pitchFamily="34" charset="0"/>
+              </a:rPr>
+              <a:t>Preuve : 01-project-setup/mysql-api-success.png</a:t>
+            </a:r>
+            <a:endParaRPr lang="en-US" sz="900">
+              <a:solidFill>
+                <a:srgbClr val="5EEAD4"/>
+              </a:solidFill>
+              <a:latin typeface="Segoe UI" panose="020B0502040204020203" pitchFamily="34" charset="0"/>
+            </a:endParaRPr>
+          </a:p>
+        </p:txBody>
+      </p:sp>
+      <p:sp>
+        <p:nvSpPr>
+          <p:cNvPr id="7" name="TextBox 6"/>
+          <p:cNvSpPr txBox="1"/>
+          <p:nvPr/>
+        </p:nvSpPr>
+        <p:spPr>
+          <a:xfrm>
+            <a:off x="11582400" y="6438900"/>
+            <a:ext cx="381000" cy="246221"/>
+          </a:xfrm>
+          <a:prstGeom prst="rect">
+            <a:avLst/>
+          </a:prstGeom>
+          <a:noFill/>
+        </p:spPr>
+        <p:txBody>
+          <a:bodyPr vert="horz" rtlCol="0">
+            <a:spAutoFit/>
+          </a:bodyPr>
+          <a:lstStyle/>
+          <a:p>
+            <a:r>
+              <a:rPr lang="en-US" sz="1000" smtClean="0">
+                <a:solidFill>
+                  <a:srgbClr val="E1E1E1"/>
+                </a:solidFill>
+                <a:latin typeface="Segoe UI" panose="020B0502040204020203" pitchFamily="34" charset="0"/>
+              </a:rPr>
+              <a:t>8</a:t>
+            </a:r>
+            <a:endParaRPr lang="en-US" sz="1000">
+              <a:solidFill>
+                <a:srgbClr val="E1E1E1"/>
+              </a:solidFill>
+              <a:latin typeface="Segoe UI" panose="020B0502040204020203" pitchFamily="34" charset="0"/>
+            </a:endParaRPr>
+          </a:p>
+        </p:txBody>
+      </p:sp>
+    </p:spTree>
+    <p:extLst>
+      <p:ext uri="{BB962C8B-B14F-4D97-AF65-F5344CB8AC3E}">
+        <p14:creationId xmlns:p14="http://schemas.microsoft.com/office/powerpoint/2010/main" val="2158967934"/>
+      </p:ext>
+    </p:extLst>
+  </p:cSld>
+  <p:clrMapOvr>
+    <a:masterClrMapping/>
+  </p:clrMapOvr>
+</p:sld>
+</file>
+
+<file path=ppt/slides/slide9.xml><?xml version="1.0" encoding="utf-8"?>
+<p:sld xmlns:a="http://schemas.openxmlformats.org/drawingml/2006/main" xmlns:r="http://schemas.openxmlformats.org/officeDocument/2006/relationships" xmlns:p="http://schemas.openxmlformats.org/presentationml/2006/main">
+  <p:cSld>
+    <p:bg>
+      <p:bgPr>
+        <a:solidFill>
+          <a:srgbClr val="0F272A"/>
+        </a:solidFill>
+        <a:effectLst/>
+      </p:bgPr>
+    </p:bg>
+    <p:spTree>
+      <p:nvGrpSpPr>
+        <p:cNvPr id="1" name=""/>
+        <p:cNvGrpSpPr/>
+        <p:nvPr/>
+      </p:nvGrpSpPr>
+      <p:grpSpPr>
+        <a:xfrm>
+          <a:off x="0" y="0"/>
+          <a:ext cx="0" cy="0"/>
+          <a:chOff x="0" y="0"/>
+          <a:chExt cx="0" cy="0"/>
+        </a:xfrm>
+      </p:grpSpPr>
+      <p:sp>
+        <p:nvSpPr>
+          <p:cNvPr id="2" name="TextBox 1"/>
+          <p:cNvSpPr txBox="1"/>
+          <p:nvPr/>
+        </p:nvSpPr>
+        <p:spPr>
+          <a:xfrm>
+            <a:off x="381000" y="152400"/>
+            <a:ext cx="10795000" cy="261610"/>
+          </a:xfrm>
+          <a:prstGeom prst="rect">
+            <a:avLst/>
+          </a:prstGeom>
+          <a:noFill/>
+        </p:spPr>
+        <p:txBody>
+          <a:bodyPr vert="horz" rtlCol="0">
+            <a:spAutoFit/>
+          </a:bodyPr>
+          <a:lstStyle/>
+          <a:p>
+            <a:r>
+              <a:rPr lang="en-US" sz="1100" smtClean="0">
+                <a:solidFill>
+                  <a:srgbClr val="5EEAD4"/>
+                </a:solidFill>
+                <a:latin typeface="Segoe UI" panose="020B0502040204020203" pitchFamily="34" charset="0"/>
+              </a:rPr>
+              <a:t>EVENTSPROJECT  /  MODULE TACHE</a:t>
+            </a:r>
+            <a:endParaRPr lang="en-US" sz="1100">
+              <a:solidFill>
+                <a:srgbClr val="5EEAD4"/>
+              </a:solidFill>
+              <a:latin typeface="Segoe UI" panose="020B0502040204020203" pitchFamily="34" charset="0"/>
+            </a:endParaRPr>
+          </a:p>
+        </p:txBody>
+      </p:sp>
+      <p:sp>
+        <p:nvSpPr>
+          <p:cNvPr id="3" name="TextBox 2"/>
+          <p:cNvSpPr txBox="1"/>
+          <p:nvPr/>
+        </p:nvSpPr>
+        <p:spPr>
+          <a:xfrm>
+            <a:off x="381000" y="533400"/>
+            <a:ext cx="11430000" cy="523220"/>
+          </a:xfrm>
+          <a:prstGeom prst="rect">
+            <a:avLst/>
+          </a:prstGeom>
+          <a:noFill/>
+        </p:spPr>
+        <p:txBody>
+          <a:bodyPr vert="horz" rtlCol="0">
+            <a:spAutoFit/>
+          </a:bodyPr>
+          <a:lstStyle/>
+          <a:p>
+            <a:r>
+              <a:rPr lang="en-US" sz="2800" smtClean="0">
+                <a:solidFill>
+                  <a:srgbClr val="FFFFFF"/>
+                </a:solidFill>
+                <a:latin typeface="Segoe UI" panose="020B0502040204020203" pitchFamily="34" charset="0"/>
+              </a:rPr>
+              <a:t>Des tests ? trois niveaux</a:t>
+            </a:r>
+            <a:endParaRPr lang="en-US" sz="2800">
+              <a:solidFill>
+                <a:srgbClr val="FFFFFF"/>
+              </a:solidFill>
+              <a:latin typeface="Segoe UI" panose="020B0502040204020203" pitchFamily="34" charset="0"/>
+            </a:endParaRPr>
+          </a:p>
+        </p:txBody>
+      </p:sp>
+      <p:sp>
+        <p:nvSpPr>
+          <p:cNvPr id="4" name="TextBox 3"/>
+          <p:cNvSpPr txBox="1"/>
+          <p:nvPr/>
+        </p:nvSpPr>
+        <p:spPr>
+          <a:xfrm>
+            <a:off x="381000" y="1244600"/>
+            <a:ext cx="11430000" cy="338554"/>
+          </a:xfrm>
+          <a:prstGeom prst="rect">
+            <a:avLst/>
+          </a:prstGeom>
+          <a:noFill/>
+        </p:spPr>
+        <p:txBody>
+          <a:bodyPr vert="horz" rtlCol="0">
+            <a:spAutoFit/>
+          </a:bodyPr>
+          <a:lstStyle/>
+          <a:p>
+            <a:r>
+              <a:rPr lang="en-US" sz="1600" smtClean="0">
+                <a:solidFill>
+                  <a:srgbClr val="E1E1E1"/>
+                </a:solidFill>
+                <a:latin typeface="Segoe UI" panose="020B0502040204020203" pitchFamily="34" charset="0"/>
+              </a:rPr>
+              <a:t>18 tests r?ussis : service Mockito, contrat HTTP et int?gration JPA/H2 sans mocks.</a:t>
+            </a:r>
+            <a:endParaRPr lang="en-US" sz="1600">
+              <a:solidFill>
+                <a:srgbClr val="E1E1E1"/>
+              </a:solidFill>
+              <a:latin typeface="Segoe UI" panose="020B0502040204020203" pitchFamily="34" charset="0"/>
+            </a:endParaRPr>
+          </a:p>
+        </p:txBody>
+      </p:sp>
+      <p:pic>
+        <p:nvPicPr>
+          <p:cNvPr id="5" name="Picture 4"/>
+          <p:cNvPicPr>
+            <a:picLocks noChangeAspect="1"/>
+          </p:cNvPicPr>
+          <p:nvPr/>
+        </p:nvPicPr>
+        <p:blipFill>
+          <a:blip r:embed="rId3">
+            <a:extLst>
+              <a:ext uri="{28A0092B-C50C-407E-A947-70E740481C1C}">
+                <a14:useLocalDpi xmlns:a14="http://schemas.microsoft.com/office/drawing/2010/main" val="0"/>
+              </a:ext>
+            </a:extLst>
+          </a:blip>
+          <a:stretch>
+            <a:fillRect/>
+          </a:stretch>
+        </p:blipFill>
+        <p:spPr>
+          <a:xfrm>
+            <a:off x="1952465" y="1981200"/>
+            <a:ext cx="8287071" cy="4318000"/>
+          </a:xfrm>
+          <a:prstGeom prst="rect">
+            <a:avLst/>
+          </a:prstGeom>
+        </p:spPr>
+      </p:pic>
+      <p:sp>
+        <p:nvSpPr>
+          <p:cNvPr id="6" name="TextBox 5"/>
+          <p:cNvSpPr txBox="1"/>
+          <p:nvPr/>
+        </p:nvSpPr>
+        <p:spPr>
+          <a:xfrm>
+            <a:off x="381000" y="6400800"/>
+            <a:ext cx="10795000" cy="230832"/>
+          </a:xfrm>
+          <a:prstGeom prst="rect">
+            <a:avLst/>
+          </a:prstGeom>
+          <a:noFill/>
+        </p:spPr>
+        <p:txBody>
+          <a:bodyPr vert="horz" rtlCol="0">
+            <a:spAutoFit/>
+          </a:bodyPr>
+          <a:lstStyle/>
+          <a:p>
+            <a:r>
+              <a:rPr lang="en-US" sz="900" smtClean="0">
+                <a:solidFill>
+                  <a:srgbClr val="5EEAD4"/>
+                </a:solidFill>
+                <a:latin typeface="Segoe UI" panose="020B0502040204020203" pitchFamily="34" charset="0"/>
+              </a:rPr>
+              <a:t>Preuve : 04-unit-tests/tests-success.png</a:t>
+            </a:r>
+            <a:endParaRPr lang="en-US" sz="900">
+              <a:solidFill>
+                <a:srgbClr val="5EEAD4"/>
+              </a:solidFill>
+              <a:latin typeface="Segoe UI" panose="020B0502040204020203" pitchFamily="34" charset="0"/>
+            </a:endParaRPr>
+          </a:p>
+        </p:txBody>
+      </p:sp>
+      <p:sp>
+        <p:nvSpPr>
+          <p:cNvPr id="7" name="TextBox 6"/>
+          <p:cNvSpPr txBox="1"/>
+          <p:nvPr/>
+        </p:nvSpPr>
+        <p:spPr>
+          <a:xfrm>
+            <a:off x="11582400" y="6438900"/>
+            <a:ext cx="381000" cy="246221"/>
+          </a:xfrm>
+          <a:prstGeom prst="rect">
+            <a:avLst/>
+          </a:prstGeom>
+          <a:noFill/>
+        </p:spPr>
+        <p:txBody>
+          <a:bodyPr vert="horz" rtlCol="0">
+            <a:spAutoFit/>
+          </a:bodyPr>
+          <a:lstStyle/>
+          <a:p>
+            <a:r>
+              <a:rPr lang="en-US" sz="1000" smtClean="0">
+                <a:solidFill>
+                  <a:srgbClr val="E1E1E1"/>
+                </a:solidFill>
+                <a:latin typeface="Segoe UI" panose="020B0502040204020203" pitchFamily="34" charset="0"/>
+              </a:rPr>
+              <a:t>9</a:t>
+            </a:r>
+            <a:endParaRPr lang="en-US" sz="1000">
+              <a:solidFill>
+                <a:srgbClr val="E1E1E1"/>
+              </a:solidFill>
+              <a:latin typeface="Segoe UI" panose="020B0502040204020203" pitchFamily="34" charset="0"/>
+            </a:endParaRPr>
+          </a:p>
+        </p:txBody>
+      </p:sp>
+    </p:spTree>
+    <p:extLst>
+      <p:ext uri="{BB962C8B-B14F-4D97-AF65-F5344CB8AC3E}">
+        <p14:creationId xmlns:p14="http://schemas.microsoft.com/office/powerpoint/2010/main" val="915908606"/>
       </p:ext>
     </p:extLst>
   </p:cSld>

</xml_diff>